<commit_message>
docs: refresh 39-sequence handoff checkpoint
</commit_message>
<xml_diff>
--- a/reports/GRT360_Research_Handoff_2026-08-09.pptx
+++ b/reports/GRT360_Research_Handoff_2026-08-09.pptx
@@ -2,21 +2,21 @@
 <file path=ppt/presentation.xml><?xml version="1.0" encoding="utf-8"?>
 <p:presentation xmlns:p="http://schemas.openxmlformats.org/presentationml/2006/main">
   <p:sldMasterIdLst>
-    <p:sldMasterId xmlns:r="http://schemas.openxmlformats.org/officeDocument/2006/relationships" id="2147483648" r:id="Rc5e7ed6e3af340de"/>
+    <p:sldMasterId xmlns:r="http://schemas.openxmlformats.org/officeDocument/2006/relationships" id="2147483648" r:id="Re0c752bd79f7458c"/>
   </p:sldMasterIdLst>
   <p:notesMasterIdLst>
-    <p:notesMasterId xmlns:r="http://schemas.openxmlformats.org/officeDocument/2006/relationships" r:id="Rf481958435a74fa2"/>
+    <p:notesMasterId xmlns:r="http://schemas.openxmlformats.org/officeDocument/2006/relationships" r:id="Rf2d74faa61b54ed1"/>
   </p:notesMasterIdLst>
   <p:sldIdLst>
-    <p:sldId xmlns:r="http://schemas.openxmlformats.org/officeDocument/2006/relationships" id="256" r:id="R352737334bd04742"/>
-    <p:sldId xmlns:r="http://schemas.openxmlformats.org/officeDocument/2006/relationships" id="257" r:id="R4a2b472e29764fc6"/>
-    <p:sldId xmlns:r="http://schemas.openxmlformats.org/officeDocument/2006/relationships" id="258" r:id="R5bfd9dff3e6f4ebb"/>
-    <p:sldId xmlns:r="http://schemas.openxmlformats.org/officeDocument/2006/relationships" id="259" r:id="R59d74350440e4e61"/>
-    <p:sldId xmlns:r="http://schemas.openxmlformats.org/officeDocument/2006/relationships" id="260" r:id="R1fe0ff4cd66a42a7"/>
-    <p:sldId xmlns:r="http://schemas.openxmlformats.org/officeDocument/2006/relationships" id="261" r:id="Rf03b0d9e97ca458b"/>
-    <p:sldId xmlns:r="http://schemas.openxmlformats.org/officeDocument/2006/relationships" id="262" r:id="R778c1b0cfcd242c1"/>
-    <p:sldId xmlns:r="http://schemas.openxmlformats.org/officeDocument/2006/relationships" id="263" r:id="Rcba4188373fe46e6"/>
-    <p:sldId xmlns:r="http://schemas.openxmlformats.org/officeDocument/2006/relationships" id="264" r:id="R0f0748bd82d3486a"/>
+    <p:sldId xmlns:r="http://schemas.openxmlformats.org/officeDocument/2006/relationships" id="256" r:id="R8ed0a508b63e4cee"/>
+    <p:sldId xmlns:r="http://schemas.openxmlformats.org/officeDocument/2006/relationships" id="257" r:id="R1d3f9829bee04170"/>
+    <p:sldId xmlns:r="http://schemas.openxmlformats.org/officeDocument/2006/relationships" id="258" r:id="R99126ce6193e466f"/>
+    <p:sldId xmlns:r="http://schemas.openxmlformats.org/officeDocument/2006/relationships" id="259" r:id="Rbabfcce255a24317"/>
+    <p:sldId xmlns:r="http://schemas.openxmlformats.org/officeDocument/2006/relationships" id="260" r:id="R3b8e2c525c1241b5"/>
+    <p:sldId xmlns:r="http://schemas.openxmlformats.org/officeDocument/2006/relationships" id="261" r:id="Rf3a9788fcf3a44ff"/>
+    <p:sldId xmlns:r="http://schemas.openxmlformats.org/officeDocument/2006/relationships" id="262" r:id="R6f4c045b87e74a42"/>
+    <p:sldId xmlns:r="http://schemas.openxmlformats.org/officeDocument/2006/relationships" id="263" r:id="R61bf45501a114c52"/>
+    <p:sldId xmlns:r="http://schemas.openxmlformats.org/officeDocument/2006/relationships" id="264" r:id="R9252584f0203402a"/>
   </p:sldIdLst>
   <p:sldSz cx="12192000" cy="6858000"/>
   <p:notesSz cx="6858000" cy="9144000"/>
@@ -540,7 +540,7 @@
           </a:p>
           <a:p xmlns:a="http://schemas.openxmlformats.org/drawingml/2006/main">
             <a:r>
-              <a:t>- D:/instan/pano360/runs/grt360_20260809/ablation_erpwrap_29seq/bakeoff.json</a:t>
+              <a:t>- D:/instan/pano360/runs/grt360_20260809/ablation_erpwrap_39seq/bakeoff.json</a:t>
             </a:r>
           </a:p>
         </p:txBody>
@@ -775,7 +775,7 @@
           </a:p>
           <a:p xmlns:a="http://schemas.openxmlformats.org/drawingml/2006/main">
             <a:r>
-              <a:t>- D:/instan/pano360/runs/grt360_20260809/ablation_erpwrap_29seq/bakeoff.json</a:t>
+              <a:t>- D:/instan/pano360/runs/grt360_20260809/ablation_erpwrap_39seq/bakeoff.json</a:t>
             </a:r>
           </a:p>
           <a:p xmlns:a="http://schemas.openxmlformats.org/drawingml/2006/main">
@@ -855,7 +855,7 @@
           </a:p>
           <a:p xmlns:a="http://schemas.openxmlformats.org/drawingml/2006/main">
             <a:r>
-              <a:t>- D:/instan/pano360/runs/grt360_20260809/ablation_erpwrap_29seq/bakeoff.json</a:t>
+              <a:t>- D:/instan/pano360/runs/grt360_20260809/ablation_erpwrap_39seq/bakeoff.json</a:t>
             </a:r>
           </a:p>
           <a:p xmlns:a="http://schemas.openxmlformats.org/drawingml/2006/main">
@@ -1173,7 +1173,7 @@
   </p:cSld>
   <p:clrMap bg1="lt1" tx1="dk1" bg2="lt2" tx2="dk2" accent1="accent1" accent2="accent2" accent3="accent3" accent4="accent4" accent5="accent5" accent6="accent6" hlink="hlink" folHlink="folHlink"/>
   <p:sldLayoutIdLst>
-    <p:sldLayoutId xmlns:r="http://schemas.openxmlformats.org/officeDocument/2006/relationships" id="2147483649" r:id="Rc8f20973567b4954"/>
+    <p:sldLayoutId xmlns:r="http://schemas.openxmlformats.org/officeDocument/2006/relationships" id="2147483649" r:id="R0d81f62c5c30487f"/>
   </p:sldLayoutIdLst>
   <p:txStyles>
     <p:titleStyle>
@@ -1959,10 +1959,10 @@
               <c:formatCode>0.0</c:formatCode>
               <c:ptCount val="2"/>
               <c:pt idx="0">
-                <c:v>0.486</c:v>
+                <c:v>0.4988</c:v>
               </c:pt>
               <c:pt idx="1">
-                <c:v>0.5452</c:v>
+                <c:v>0.5578</c:v>
               </c:pt>
             </c:numLit>
           </c:val>
@@ -1994,10 +1994,10 @@
               <c:formatCode>0.0</c:formatCode>
               <c:ptCount val="2"/>
               <c:pt idx="0">
-                <c:v>0.3892</c:v>
+                <c:v>0.406</c:v>
               </c:pt>
               <c:pt idx="1">
-                <c:v>0.4217</c:v>
+                <c:v>0.4397</c:v>
               </c:pt>
             </c:numLit>
           </c:val>
@@ -2170,7 +2170,7 @@
           <p:cNvPr id="6" name="">
             <a:extLst xmlns:a="http://schemas.openxmlformats.org/drawingml/2006/main">
               <a:ext uri="{FF2B5EF4-FFF2-40B4-BE49-F238E27FC236}">
-                <a16:creationId xmlns:a16="http://schemas.microsoft.com/office/drawing/2014/main" id="{227F3348-960E-4882-9570-66D9F54BEC12}"/>
+                <a16:creationId xmlns:a16="http://schemas.microsoft.com/office/drawing/2014/main" id="{C5466B52-1EFA-4156-A7B9-07C9AB0869C4}"/>
               </a:ext>
             </a:extLst>
           </p:cNvPr>
@@ -2201,7 +2201,7 @@
           <p:cNvPr id="2" name="">
             <a:extLst xmlns:a="http://schemas.openxmlformats.org/drawingml/2006/main">
               <a:ext uri="{FF2B5EF4-FFF2-40B4-BE49-F238E27FC236}">
-                <a16:creationId xmlns:a16="http://schemas.microsoft.com/office/drawing/2014/main" id="{29361C3B-8982-4B11-A79B-13A30321DB44}"/>
+                <a16:creationId xmlns:a16="http://schemas.microsoft.com/office/drawing/2014/main" id="{05AFF9BF-D6D0-4145-876A-3754AE0015AC}"/>
               </a:ext>
             </a:extLst>
           </p:cNvPr>
@@ -2251,7 +2251,7 @@
           <p:cNvPr id="3" name="">
             <a:extLst xmlns:a="http://schemas.openxmlformats.org/drawingml/2006/main">
               <a:ext uri="{FF2B5EF4-FFF2-40B4-BE49-F238E27FC236}">
-                <a16:creationId xmlns:a16="http://schemas.microsoft.com/office/drawing/2014/main" id="{09875683-4A12-433E-87F8-194FCC088518}"/>
+                <a16:creationId xmlns:a16="http://schemas.microsoft.com/office/drawing/2014/main" id="{E46F739F-0DCE-4B3F-9966-E06E24826B9A}"/>
               </a:ext>
             </a:extLst>
           </p:cNvPr>
@@ -2301,7 +2301,7 @@
           <p:cNvPr id="4" name="">
             <a:extLst xmlns:a="http://schemas.openxmlformats.org/drawingml/2006/main">
               <a:ext uri="{FF2B5EF4-FFF2-40B4-BE49-F238E27FC236}">
-                <a16:creationId xmlns:a16="http://schemas.microsoft.com/office/drawing/2014/main" id="{01E22B3C-D2DE-47F3-988F-DF7F5A2501A7}"/>
+                <a16:creationId xmlns:a16="http://schemas.microsoft.com/office/drawing/2014/main" id="{19AE557F-F964-4E3D-B584-CC69ACFEC2EC}"/>
               </a:ext>
             </a:extLst>
           </p:cNvPr>
@@ -2351,7 +2351,7 @@
           <p:cNvPr id="5" name="">
             <a:extLst xmlns:a="http://schemas.openxmlformats.org/drawingml/2006/main">
               <a:ext uri="{FF2B5EF4-FFF2-40B4-BE49-F238E27FC236}">
-                <a16:creationId xmlns:a16="http://schemas.microsoft.com/office/drawing/2014/main" id="{DE12D42C-4419-45C1-B830-FD9483C92E52}"/>
+                <a16:creationId xmlns:a16="http://schemas.microsoft.com/office/drawing/2014/main" id="{4037BF07-6292-4B7C-92A5-F57CA72F73A5}"/>
               </a:ext>
             </a:extLst>
           </p:cNvPr>
@@ -2399,7 +2399,7 @@
     </p:spTree>
     <p:extLst>
       <p:ext uri="{BB962C8B-B14F-4D97-AF65-F5344CB8AC3E}">
-        <p14:creationId xmlns:p14="http://schemas.microsoft.com/office/powerpoint/2010/main" val="926687992"/>
+        <p14:creationId xmlns:p14="http://schemas.microsoft.com/office/powerpoint/2010/main" val="586629733"/>
       </p:ext>
     </p:extLst>
   </p:cSld>
@@ -2430,7 +2430,7 @@
           <p:cNvPr id="19" name="">
             <a:extLst xmlns:a="http://schemas.openxmlformats.org/drawingml/2006/main">
               <a:ext uri="{FF2B5EF4-FFF2-40B4-BE49-F238E27FC236}">
-                <a16:creationId xmlns:a16="http://schemas.microsoft.com/office/drawing/2014/main" id="{2942176B-EEEB-4BC8-A2A7-A3A6EA3E18C6}"/>
+                <a16:creationId xmlns:a16="http://schemas.microsoft.com/office/drawing/2014/main" id="{D5EBD2C4-A006-4839-8DBA-689B9F3F9EDA}"/>
               </a:ext>
             </a:extLst>
           </p:cNvPr>
@@ -2480,7 +2480,7 @@
           <p:cNvPr id="2" name="">
             <a:extLst xmlns:a="http://schemas.openxmlformats.org/drawingml/2006/main">
               <a:ext uri="{FF2B5EF4-FFF2-40B4-BE49-F238E27FC236}">
-                <a16:creationId xmlns:a16="http://schemas.microsoft.com/office/drawing/2014/main" id="{6D803766-77F4-4FC6-834A-A6830029127D}"/>
+                <a16:creationId xmlns:a16="http://schemas.microsoft.com/office/drawing/2014/main" id="{12C16453-96C2-47C8-BFB4-CA576C23F4CC}"/>
               </a:ext>
             </a:extLst>
           </p:cNvPr>
@@ -2530,7 +2530,7 @@
           <p:cNvPr id="3" name="">
             <a:extLst xmlns:a="http://schemas.openxmlformats.org/drawingml/2006/main">
               <a:ext uri="{FF2B5EF4-FFF2-40B4-BE49-F238E27FC236}">
-                <a16:creationId xmlns:a16="http://schemas.microsoft.com/office/drawing/2014/main" id="{3CDBABFC-46FE-40AE-AF21-3DCC2FCF5FEF}"/>
+                <a16:creationId xmlns:a16="http://schemas.microsoft.com/office/drawing/2014/main" id="{A728901F-6952-4B21-B294-6AE7D17912F5}"/>
               </a:ext>
             </a:extLst>
           </p:cNvPr>
@@ -2561,7 +2561,7 @@
           <p:cNvPr id="4" name="">
             <a:extLst xmlns:a="http://schemas.openxmlformats.org/drawingml/2006/main">
               <a:ext uri="{FF2B5EF4-FFF2-40B4-BE49-F238E27FC236}">
-                <a16:creationId xmlns:a16="http://schemas.microsoft.com/office/drawing/2014/main" id="{3B510A80-0B93-4E51-AAC9-654189269ABD}"/>
+                <a16:creationId xmlns:a16="http://schemas.microsoft.com/office/drawing/2014/main" id="{DD914055-48E5-4DE3-9AD1-79654CE14C76}"/>
               </a:ext>
             </a:extLst>
           </p:cNvPr>
@@ -2611,7 +2611,7 @@
           <p:cNvPr id="5" name="">
             <a:extLst xmlns:a="http://schemas.openxmlformats.org/drawingml/2006/main">
               <a:ext uri="{FF2B5EF4-FFF2-40B4-BE49-F238E27FC236}">
-                <a16:creationId xmlns:a16="http://schemas.microsoft.com/office/drawing/2014/main" id="{562B75DE-A417-4873-B015-C3505048002E}"/>
+                <a16:creationId xmlns:a16="http://schemas.microsoft.com/office/drawing/2014/main" id="{E5F20254-6A06-4176-B6C3-B3B43A9C30EE}"/>
               </a:ext>
             </a:extLst>
           </p:cNvPr>
@@ -2651,7 +2651,7 @@
                   <a:srgbClr val="3D8DFF"/>
                 </a:solidFill>
               </a:rPr>
-              <a:t>0.4860</a:t>
+              <a:t>0.4988</a:t>
             </a:r>
           </a:p>
         </p:txBody>
@@ -2661,7 +2661,7 @@
           <p:cNvPr id="6" name="">
             <a:extLst xmlns:a="http://schemas.openxmlformats.org/drawingml/2006/main">
               <a:ext uri="{FF2B5EF4-FFF2-40B4-BE49-F238E27FC236}">
-                <a16:creationId xmlns:a16="http://schemas.microsoft.com/office/drawing/2014/main" id="{62DABBE3-5016-447D-A8FA-7EA5E306CF0E}"/>
+                <a16:creationId xmlns:a16="http://schemas.microsoft.com/office/drawing/2014/main" id="{F390DB62-0B31-4E87-9601-44B0F129448B}"/>
               </a:ext>
             </a:extLst>
           </p:cNvPr>
@@ -2701,7 +2701,7 @@
                   <a:srgbClr val="5B6470"/>
                 </a:solidFill>
               </a:rPr>
-              <a:t>29 条序列 ERP-wrap AUC</a:t>
+              <a:t>39 条序列 ERP-wrap AUC</a:t>
             </a:r>
           </a:p>
         </p:txBody>
@@ -2711,7 +2711,7 @@
           <p:cNvPr id="7" name="">
             <a:extLst xmlns:a="http://schemas.openxmlformats.org/drawingml/2006/main">
               <a:ext uri="{FF2B5EF4-FFF2-40B4-BE49-F238E27FC236}">
-                <a16:creationId xmlns:a16="http://schemas.microsoft.com/office/drawing/2014/main" id="{59A92CED-4564-4E19-8DA8-5D7D99F07E71}"/>
+                <a16:creationId xmlns:a16="http://schemas.microsoft.com/office/drawing/2014/main" id="{C6844220-BD41-413C-81C8-B1EC3E609A62}"/>
               </a:ext>
             </a:extLst>
           </p:cNvPr>
@@ -2751,7 +2751,7 @@
                   <a:srgbClr val="3D8DFF"/>
                 </a:solidFill>
               </a:rPr>
-              <a:t>0.5452</a:t>
+              <a:t>0.5578</a:t>
             </a:r>
           </a:p>
         </p:txBody>
@@ -2761,7 +2761,7 @@
           <p:cNvPr id="8" name="">
             <a:extLst xmlns:a="http://schemas.openxmlformats.org/drawingml/2006/main">
               <a:ext uri="{FF2B5EF4-FFF2-40B4-BE49-F238E27FC236}">
-                <a16:creationId xmlns:a16="http://schemas.microsoft.com/office/drawing/2014/main" id="{63B052D5-AE8A-421D-99D4-C8BA4D874313}"/>
+                <a16:creationId xmlns:a16="http://schemas.microsoft.com/office/drawing/2014/main" id="{C8DDA21D-359A-4A02-B242-BF48B6DA29FE}"/>
               </a:ext>
             </a:extLst>
           </p:cNvPr>
@@ -2801,7 +2801,7 @@
                   <a:srgbClr val="5B6470"/>
                 </a:solidFill>
               </a:rPr>
-              <a:t>29 条序列 ERP-wrap SR</a:t>
+              <a:t>39 条序列 ERP-wrap SR</a:t>
             </a:r>
           </a:p>
         </p:txBody>
@@ -2811,7 +2811,7 @@
           <p:cNvPr id="9" name="">
             <a:extLst xmlns:a="http://schemas.openxmlformats.org/drawingml/2006/main">
               <a:ext uri="{FF2B5EF4-FFF2-40B4-BE49-F238E27FC236}">
-                <a16:creationId xmlns:a16="http://schemas.microsoft.com/office/drawing/2014/main" id="{508ACB8C-C91D-4B50-861D-ABD6FD232C26}"/>
+                <a16:creationId xmlns:a16="http://schemas.microsoft.com/office/drawing/2014/main" id="{0825C2F1-68E4-4D6D-AA48-A9A10AC39926}"/>
               </a:ext>
             </a:extLst>
           </p:cNvPr>
@@ -2842,7 +2842,7 @@
           <p:cNvPr id="10" name="">
             <a:extLst xmlns:a="http://schemas.openxmlformats.org/drawingml/2006/main">
               <a:ext uri="{FF2B5EF4-FFF2-40B4-BE49-F238E27FC236}">
-                <a16:creationId xmlns:a16="http://schemas.microsoft.com/office/drawing/2014/main" id="{76D1D9E7-546F-4222-9B8E-27B4C2DDC652}"/>
+                <a16:creationId xmlns:a16="http://schemas.microsoft.com/office/drawing/2014/main" id="{17AFAB5A-8310-4A76-BC8C-0D124304AFA9}"/>
               </a:ext>
             </a:extLst>
           </p:cNvPr>
@@ -2892,7 +2892,7 @@
           <p:cNvPr id="11" name="">
             <a:extLst xmlns:a="http://schemas.openxmlformats.org/drawingml/2006/main">
               <a:ext uri="{FF2B5EF4-FFF2-40B4-BE49-F238E27FC236}">
-                <a16:creationId xmlns:a16="http://schemas.microsoft.com/office/drawing/2014/main" id="{2B677126-2532-4AAC-8D4D-48913CAED7A9}"/>
+                <a16:creationId xmlns:a16="http://schemas.microsoft.com/office/drawing/2014/main" id="{1CDED290-53C8-49DF-88F1-59DEE462A560}"/>
               </a:ext>
             </a:extLst>
           </p:cNvPr>
@@ -2942,7 +2942,7 @@
           <p:cNvPr id="12" name="">
             <a:extLst xmlns:a="http://schemas.openxmlformats.org/drawingml/2006/main">
               <a:ext uri="{FF2B5EF4-FFF2-40B4-BE49-F238E27FC236}">
-                <a16:creationId xmlns:a16="http://schemas.microsoft.com/office/drawing/2014/main" id="{B641E2D3-262F-4B83-8247-1D2911FFF8E9}"/>
+                <a16:creationId xmlns:a16="http://schemas.microsoft.com/office/drawing/2014/main" id="{6B1DE86B-72DE-4DA6-96BC-0C07B3A447D3}"/>
               </a:ext>
             </a:extLst>
           </p:cNvPr>
@@ -2992,7 +2992,7 @@
           <p:cNvPr id="13" name="">
             <a:extLst xmlns:a="http://schemas.openxmlformats.org/drawingml/2006/main">
               <a:ext uri="{FF2B5EF4-FFF2-40B4-BE49-F238E27FC236}">
-                <a16:creationId xmlns:a16="http://schemas.microsoft.com/office/drawing/2014/main" id="{36AFA32B-B9FD-4715-8CBB-3DE26048930E}"/>
+                <a16:creationId xmlns:a16="http://schemas.microsoft.com/office/drawing/2014/main" id="{E1F211C0-E678-482F-8996-EE9342D57AD2}"/>
               </a:ext>
             </a:extLst>
           </p:cNvPr>
@@ -3042,7 +3042,7 @@
           <p:cNvPr id="14" name="">
             <a:extLst xmlns:a="http://schemas.openxmlformats.org/drawingml/2006/main">
               <a:ext uri="{FF2B5EF4-FFF2-40B4-BE49-F238E27FC236}">
-                <a16:creationId xmlns:a16="http://schemas.microsoft.com/office/drawing/2014/main" id="{D37D7C49-CEE9-467D-83C6-49CF7204A808}"/>
+                <a16:creationId xmlns:a16="http://schemas.microsoft.com/office/drawing/2014/main" id="{7D13281E-77D4-4A6B-B3D6-76F063FEF8E9}"/>
               </a:ext>
             </a:extLst>
           </p:cNvPr>
@@ -3092,7 +3092,7 @@
           <p:cNvPr id="15" name="">
             <a:extLst xmlns:a="http://schemas.openxmlformats.org/drawingml/2006/main">
               <a:ext uri="{FF2B5EF4-FFF2-40B4-BE49-F238E27FC236}">
-                <a16:creationId xmlns:a16="http://schemas.microsoft.com/office/drawing/2014/main" id="{11B46D47-591E-44C9-87F7-61EFDCC40B20}"/>
+                <a16:creationId xmlns:a16="http://schemas.microsoft.com/office/drawing/2014/main" id="{087B13CB-C8FB-44E2-8757-BFA082748299}"/>
               </a:ext>
             </a:extLst>
           </p:cNvPr>
@@ -3142,7 +3142,7 @@
           <p:cNvPr id="16" name="">
             <a:extLst xmlns:a="http://schemas.openxmlformats.org/drawingml/2006/main">
               <a:ext uri="{FF2B5EF4-FFF2-40B4-BE49-F238E27FC236}">
-                <a16:creationId xmlns:a16="http://schemas.microsoft.com/office/drawing/2014/main" id="{86DA4A40-FDEF-4D1B-883B-A6C88A1E0BF1}"/>
+                <a16:creationId xmlns:a16="http://schemas.microsoft.com/office/drawing/2014/main" id="{F6F77F64-3683-46BE-B272-47916276A07D}"/>
               </a:ext>
             </a:extLst>
           </p:cNvPr>
@@ -3173,7 +3173,7 @@
           <p:cNvPr id="17" name="">
             <a:extLst xmlns:a="http://schemas.openxmlformats.org/drawingml/2006/main">
               <a:ext uri="{FF2B5EF4-FFF2-40B4-BE49-F238E27FC236}">
-                <a16:creationId xmlns:a16="http://schemas.microsoft.com/office/drawing/2014/main" id="{79C890F3-8DD8-427E-A10A-DFE6BB065702}"/>
+                <a16:creationId xmlns:a16="http://schemas.microsoft.com/office/drawing/2014/main" id="{21D61B44-A9E1-449F-821B-D1E0B107ABEA}"/>
               </a:ext>
             </a:extLst>
           </p:cNvPr>
@@ -3223,7 +3223,7 @@
           <p:cNvPr id="18" name="">
             <a:extLst xmlns:a="http://schemas.openxmlformats.org/drawingml/2006/main">
               <a:ext uri="{FF2B5EF4-FFF2-40B4-BE49-F238E27FC236}">
-                <a16:creationId xmlns:a16="http://schemas.microsoft.com/office/drawing/2014/main" id="{DBC5052C-83D4-4940-9255-C0A1FDAE5745}"/>
+                <a16:creationId xmlns:a16="http://schemas.microsoft.com/office/drawing/2014/main" id="{14DE2014-771C-4E00-87D9-D8B8D9273C95}"/>
               </a:ext>
             </a:extLst>
           </p:cNvPr>
@@ -3271,7 +3271,7 @@
     </p:spTree>
     <p:extLst>
       <p:ext uri="{BB962C8B-B14F-4D97-AF65-F5344CB8AC3E}">
-        <p14:creationId xmlns:p14="http://schemas.microsoft.com/office/powerpoint/2010/main" val="369880208"/>
+        <p14:creationId xmlns:p14="http://schemas.microsoft.com/office/powerpoint/2010/main" val="1273585954"/>
       </p:ext>
     </p:extLst>
   </p:cSld>
@@ -3302,7 +3302,7 @@
           <p:cNvPr id="9" name="">
             <a:extLst xmlns:a="http://schemas.openxmlformats.org/drawingml/2006/main">
               <a:ext uri="{FF2B5EF4-FFF2-40B4-BE49-F238E27FC236}">
-                <a16:creationId xmlns:a16="http://schemas.microsoft.com/office/drawing/2014/main" id="{BF09D27D-9F65-456B-A0FE-362F4F276574}"/>
+                <a16:creationId xmlns:a16="http://schemas.microsoft.com/office/drawing/2014/main" id="{9C17B6A9-0052-464F-A872-2A6D01989BA5}"/>
               </a:ext>
             </a:extLst>
           </p:cNvPr>
@@ -3352,7 +3352,7 @@
           <p:cNvPr id="2" name="">
             <a:extLst xmlns:a="http://schemas.openxmlformats.org/drawingml/2006/main">
               <a:ext uri="{FF2B5EF4-FFF2-40B4-BE49-F238E27FC236}">
-                <a16:creationId xmlns:a16="http://schemas.microsoft.com/office/drawing/2014/main" id="{80A88412-9829-4B5F-82F5-92070FD61D7B}"/>
+                <a16:creationId xmlns:a16="http://schemas.microsoft.com/office/drawing/2014/main" id="{2D9576DE-CAC0-4212-9E6F-D9DBD1F9F98A}"/>
               </a:ext>
             </a:extLst>
           </p:cNvPr>
@@ -3402,7 +3402,7 @@
           <p:cNvPr id="3" name="">
             <a:extLst xmlns:a="http://schemas.openxmlformats.org/drawingml/2006/main">
               <a:ext uri="{FF2B5EF4-FFF2-40B4-BE49-F238E27FC236}">
-                <a16:creationId xmlns:a16="http://schemas.microsoft.com/office/drawing/2014/main" id="{FDB8D2A2-A8AF-450E-9F4E-D1AE541509F2}"/>
+                <a16:creationId xmlns:a16="http://schemas.microsoft.com/office/drawing/2014/main" id="{782299C7-FBB7-44EE-AA62-060C3D9F95EF}"/>
               </a:ext>
             </a:extLst>
           </p:cNvPr>
@@ -3696,7 +3696,7 @@
           <p:cNvPr id="5" name="">
             <a:extLst xmlns:a="http://schemas.openxmlformats.org/drawingml/2006/main">
               <a:ext uri="{FF2B5EF4-FFF2-40B4-BE49-F238E27FC236}">
-                <a16:creationId xmlns:a16="http://schemas.microsoft.com/office/drawing/2014/main" id="{F7C4E8C7-CB9E-4D2C-8D4A-4F17583F2A54}"/>
+                <a16:creationId xmlns:a16="http://schemas.microsoft.com/office/drawing/2014/main" id="{E7842ADA-64C0-4B9C-900A-B3CE6D38CB21}"/>
               </a:ext>
             </a:extLst>
           </p:cNvPr>
@@ -3746,7 +3746,7 @@
           <p:cNvPr id="6" name="">
             <a:extLst xmlns:a="http://schemas.openxmlformats.org/drawingml/2006/main">
               <a:ext uri="{FF2B5EF4-FFF2-40B4-BE49-F238E27FC236}">
-                <a16:creationId xmlns:a16="http://schemas.microsoft.com/office/drawing/2014/main" id="{B6B78F1A-9A3A-4478-B1EC-63BCFA566294}"/>
+                <a16:creationId xmlns:a16="http://schemas.microsoft.com/office/drawing/2014/main" id="{45747E02-A334-463F-9DE1-8DEA1481515E}"/>
               </a:ext>
             </a:extLst>
           </p:cNvPr>
@@ -3777,7 +3777,7 @@
           <p:cNvPr id="7" name="">
             <a:extLst xmlns:a="http://schemas.openxmlformats.org/drawingml/2006/main">
               <a:ext uri="{FF2B5EF4-FFF2-40B4-BE49-F238E27FC236}">
-                <a16:creationId xmlns:a16="http://schemas.microsoft.com/office/drawing/2014/main" id="{FE48D04C-0CD2-402B-97E2-D6BDAF7FA153}"/>
+                <a16:creationId xmlns:a16="http://schemas.microsoft.com/office/drawing/2014/main" id="{76032046-2D60-4DB4-9AC7-82E510159361}"/>
               </a:ext>
             </a:extLst>
           </p:cNvPr>
@@ -3827,7 +3827,7 @@
           <p:cNvPr id="8" name="">
             <a:extLst xmlns:a="http://schemas.openxmlformats.org/drawingml/2006/main">
               <a:ext uri="{FF2B5EF4-FFF2-40B4-BE49-F238E27FC236}">
-                <a16:creationId xmlns:a16="http://schemas.microsoft.com/office/drawing/2014/main" id="{C326B980-7270-4E53-9A05-FFEBC1DA8A16}"/>
+                <a16:creationId xmlns:a16="http://schemas.microsoft.com/office/drawing/2014/main" id="{97E0113F-82C3-4337-954C-AF7D2A087533}"/>
               </a:ext>
             </a:extLst>
           </p:cNvPr>
@@ -3875,7 +3875,7 @@
     </p:spTree>
     <p:extLst>
       <p:ext uri="{BB962C8B-B14F-4D97-AF65-F5344CB8AC3E}">
-        <p14:creationId xmlns:p14="http://schemas.microsoft.com/office/powerpoint/2010/main" val="243909983"/>
+        <p14:creationId xmlns:p14="http://schemas.microsoft.com/office/powerpoint/2010/main" val="713657222"/>
       </p:ext>
     </p:extLst>
   </p:cSld>
@@ -3906,7 +3906,7 @@
           <p:cNvPr id="12" name="">
             <a:extLst xmlns:a="http://schemas.openxmlformats.org/drawingml/2006/main">
               <a:ext uri="{FF2B5EF4-FFF2-40B4-BE49-F238E27FC236}">
-                <a16:creationId xmlns:a16="http://schemas.microsoft.com/office/drawing/2014/main" id="{7CE8A36F-AC5C-422D-8D24-44E342866A29}"/>
+                <a16:creationId xmlns:a16="http://schemas.microsoft.com/office/drawing/2014/main" id="{7287B5E4-3545-48E0-8CDE-3D6B6730CF38}"/>
               </a:ext>
             </a:extLst>
           </p:cNvPr>
@@ -3956,7 +3956,7 @@
           <p:cNvPr id="2" name="">
             <a:extLst xmlns:a="http://schemas.openxmlformats.org/drawingml/2006/main">
               <a:ext uri="{FF2B5EF4-FFF2-40B4-BE49-F238E27FC236}">
-                <a16:creationId xmlns:a16="http://schemas.microsoft.com/office/drawing/2014/main" id="{9430A454-FBDA-4D92-ADA4-E9D7C1D3A105}"/>
+                <a16:creationId xmlns:a16="http://schemas.microsoft.com/office/drawing/2014/main" id="{7291F4FB-F08E-4249-938E-7DC6EA2C8B0F}"/>
               </a:ext>
             </a:extLst>
           </p:cNvPr>
@@ -4006,7 +4006,7 @@
           <p:cNvPr id="3" name="">
             <a:extLst xmlns:a="http://schemas.openxmlformats.org/drawingml/2006/main">
               <a:ext uri="{FF2B5EF4-FFF2-40B4-BE49-F238E27FC236}">
-                <a16:creationId xmlns:a16="http://schemas.microsoft.com/office/drawing/2014/main" id="{1DB915F7-AE6B-415E-828A-6B150603F6ED}"/>
+                <a16:creationId xmlns:a16="http://schemas.microsoft.com/office/drawing/2014/main" id="{037EB5F0-9E2F-4FE9-9D7A-1841A4B87899}"/>
               </a:ext>
             </a:extLst>
           </p:cNvPr>
@@ -4063,7 +4063,7 @@
         </p:xfrm>
         <a:graphic xmlns:a="http://schemas.openxmlformats.org/drawingml/2006/main">
           <a:graphicData uri="http://schemas.openxmlformats.org/drawingml/2006/chart">
-            <c:chart xmlns:r="http://schemas.openxmlformats.org/officeDocument/2006/relationships" xmlns:c="http://schemas.openxmlformats.org/drawingml/2006/chart" r:id="R7808bbc001914dfe"/>
+            <c:chart xmlns:r="http://schemas.openxmlformats.org/officeDocument/2006/relationships" xmlns:c="http://schemas.openxmlformats.org/drawingml/2006/chart" r:id="R0fa546b07bb349d5"/>
           </a:graphicData>
         </a:graphic>
       </p:graphicFrame>
@@ -4072,7 +4072,7 @@
           <p:cNvPr id="5" name="">
             <a:extLst xmlns:a="http://schemas.openxmlformats.org/drawingml/2006/main">
               <a:ext uri="{FF2B5EF4-FFF2-40B4-BE49-F238E27FC236}">
-                <a16:creationId xmlns:a16="http://schemas.microsoft.com/office/drawing/2014/main" id="{6A82CDC0-6D33-4D6E-8CF9-6857D48D96BD}"/>
+                <a16:creationId xmlns:a16="http://schemas.microsoft.com/office/drawing/2014/main" id="{00CFCFCC-80B0-4DC9-8BA6-10876755A7DF}"/>
               </a:ext>
             </a:extLst>
           </p:cNvPr>
@@ -4103,7 +4103,7 @@
           <p:cNvPr id="6" name="">
             <a:extLst xmlns:a="http://schemas.openxmlformats.org/drawingml/2006/main">
               <a:ext uri="{FF2B5EF4-FFF2-40B4-BE49-F238E27FC236}">
-                <a16:creationId xmlns:a16="http://schemas.microsoft.com/office/drawing/2014/main" id="{9F0D90F9-604F-45C9-9E1B-F4178EF6268B}"/>
+                <a16:creationId xmlns:a16="http://schemas.microsoft.com/office/drawing/2014/main" id="{99B13CEB-1FDD-4FDE-BEB0-7B910F39A062}"/>
               </a:ext>
             </a:extLst>
           </p:cNvPr>
@@ -4153,7 +4153,7 @@
           <p:cNvPr id="7" name="">
             <a:extLst xmlns:a="http://schemas.openxmlformats.org/drawingml/2006/main">
               <a:ext uri="{FF2B5EF4-FFF2-40B4-BE49-F238E27FC236}">
-                <a16:creationId xmlns:a16="http://schemas.microsoft.com/office/drawing/2014/main" id="{C0DBD992-CF16-41BF-9384-C3272E9CCDA3}"/>
+                <a16:creationId xmlns:a16="http://schemas.microsoft.com/office/drawing/2014/main" id="{0FF52CBC-0D7A-45F4-AE7D-375C05A1A000}"/>
               </a:ext>
             </a:extLst>
           </p:cNvPr>
@@ -4237,7 +4237,7 @@
           <p:cNvPr id="8" name="">
             <a:extLst xmlns:a="http://schemas.openxmlformats.org/drawingml/2006/main">
               <a:ext uri="{FF2B5EF4-FFF2-40B4-BE49-F238E27FC236}">
-                <a16:creationId xmlns:a16="http://schemas.microsoft.com/office/drawing/2014/main" id="{1B517607-CE71-47A7-94E6-6042630DB2C5}"/>
+                <a16:creationId xmlns:a16="http://schemas.microsoft.com/office/drawing/2014/main" id="{576E235E-4CE7-4DA4-AF30-9AC3AEA8DDEB}"/>
               </a:ext>
             </a:extLst>
           </p:cNvPr>
@@ -4287,7 +4287,7 @@
           <p:cNvPr id="9" name="">
             <a:extLst xmlns:a="http://schemas.openxmlformats.org/drawingml/2006/main">
               <a:ext uri="{FF2B5EF4-FFF2-40B4-BE49-F238E27FC236}">
-                <a16:creationId xmlns:a16="http://schemas.microsoft.com/office/drawing/2014/main" id="{0C61EAF2-3BC2-4375-BFEE-C43C7C181106}"/>
+                <a16:creationId xmlns:a16="http://schemas.microsoft.com/office/drawing/2014/main" id="{11F47902-68CF-41C6-ACFE-D84977337BC9}"/>
               </a:ext>
             </a:extLst>
           </p:cNvPr>
@@ -4318,7 +4318,7 @@
           <p:cNvPr id="10" name="">
             <a:extLst xmlns:a="http://schemas.openxmlformats.org/drawingml/2006/main">
               <a:ext uri="{FF2B5EF4-FFF2-40B4-BE49-F238E27FC236}">
-                <a16:creationId xmlns:a16="http://schemas.microsoft.com/office/drawing/2014/main" id="{11D63BAD-8A22-448C-8C02-1049813A1DFE}"/>
+                <a16:creationId xmlns:a16="http://schemas.microsoft.com/office/drawing/2014/main" id="{58D195BB-BA70-46A3-AF1E-F5AD0BF9F42D}"/>
               </a:ext>
             </a:extLst>
           </p:cNvPr>
@@ -4368,7 +4368,7 @@
           <p:cNvPr id="11" name="">
             <a:extLst xmlns:a="http://schemas.openxmlformats.org/drawingml/2006/main">
               <a:ext uri="{FF2B5EF4-FFF2-40B4-BE49-F238E27FC236}">
-                <a16:creationId xmlns:a16="http://schemas.microsoft.com/office/drawing/2014/main" id="{76C1A28F-4881-4E3F-A701-7785D86E1309}"/>
+                <a16:creationId xmlns:a16="http://schemas.microsoft.com/office/drawing/2014/main" id="{35925B99-3695-4AB4-8819-325FA8ADD122}"/>
               </a:ext>
             </a:extLst>
           </p:cNvPr>
@@ -4416,7 +4416,7 @@
     </p:spTree>
     <p:extLst>
       <p:ext uri="{BB962C8B-B14F-4D97-AF65-F5344CB8AC3E}">
-        <p14:creationId xmlns:p14="http://schemas.microsoft.com/office/powerpoint/2010/main" val="518856460"/>
+        <p14:creationId xmlns:p14="http://schemas.microsoft.com/office/powerpoint/2010/main" val="1374299744"/>
       </p:ext>
     </p:extLst>
   </p:cSld>
@@ -4447,7 +4447,7 @@
           <p:cNvPr id="14" name="">
             <a:extLst xmlns:a="http://schemas.openxmlformats.org/drawingml/2006/main">
               <a:ext uri="{FF2B5EF4-FFF2-40B4-BE49-F238E27FC236}">
-                <a16:creationId xmlns:a16="http://schemas.microsoft.com/office/drawing/2014/main" id="{F8AE6653-0107-48FF-AA52-A484D0FCF1FB}"/>
+                <a16:creationId xmlns:a16="http://schemas.microsoft.com/office/drawing/2014/main" id="{47C5035C-A4B7-4CD2-B6CA-7B2BF2F27416}"/>
               </a:ext>
             </a:extLst>
           </p:cNvPr>
@@ -4497,7 +4497,7 @@
           <p:cNvPr id="2" name="">
             <a:extLst xmlns:a="http://schemas.openxmlformats.org/drawingml/2006/main">
               <a:ext uri="{FF2B5EF4-FFF2-40B4-BE49-F238E27FC236}">
-                <a16:creationId xmlns:a16="http://schemas.microsoft.com/office/drawing/2014/main" id="{EF6B2DFB-4324-4CC8-9C66-3605C8963A09}"/>
+                <a16:creationId xmlns:a16="http://schemas.microsoft.com/office/drawing/2014/main" id="{FD72CA5B-5B6D-4FB8-A68E-4E11C38EF02A}"/>
               </a:ext>
             </a:extLst>
           </p:cNvPr>
@@ -4537,7 +4537,7 @@
                   <a:srgbClr val="0B0D10"/>
                 </a:solidFill>
               </a:rPr>
-              <a:t>ERP 环形采样在 29 条序列上形成稳定增益</a:t>
+              <a:t>ERP 环形采样在 39 条序列上形成稳定增益</a:t>
             </a:r>
           </a:p>
         </p:txBody>
@@ -4547,7 +4547,7 @@
           <p:cNvPr id="3" name="">
             <a:extLst xmlns:a="http://schemas.openxmlformats.org/drawingml/2006/main">
               <a:ext uri="{FF2B5EF4-FFF2-40B4-BE49-F238E27FC236}">
-                <a16:creationId xmlns:a16="http://schemas.microsoft.com/office/drawing/2014/main" id="{51A800F4-1C1A-4175-B5F0-36862280AE4A}"/>
+                <a16:creationId xmlns:a16="http://schemas.microsoft.com/office/drawing/2014/main" id="{1E4FFC7A-D8CA-49C8-8CD9-25F6325BE182}"/>
               </a:ext>
             </a:extLst>
           </p:cNvPr>
@@ -4604,7 +4604,7 @@
         </p:xfrm>
         <a:graphic xmlns:a="http://schemas.openxmlformats.org/drawingml/2006/main">
           <a:graphicData uri="http://schemas.openxmlformats.org/drawingml/2006/chart">
-            <c:chart xmlns:r="http://schemas.openxmlformats.org/officeDocument/2006/relationships" xmlns:c="http://schemas.openxmlformats.org/drawingml/2006/chart" r:id="Raa1d381856854053"/>
+            <c:chart xmlns:r="http://schemas.openxmlformats.org/officeDocument/2006/relationships" xmlns:c="http://schemas.openxmlformats.org/drawingml/2006/chart" r:id="R3bc70531eeb24ae7"/>
           </a:graphicData>
         </a:graphic>
       </p:graphicFrame>
@@ -4613,7 +4613,7 @@
           <p:cNvPr id="5" name="">
             <a:extLst xmlns:a="http://schemas.openxmlformats.org/drawingml/2006/main">
               <a:ext uri="{FF2B5EF4-FFF2-40B4-BE49-F238E27FC236}">
-                <a16:creationId xmlns:a16="http://schemas.microsoft.com/office/drawing/2014/main" id="{97160ED0-4F1C-4067-A360-896F664C074A}"/>
+                <a16:creationId xmlns:a16="http://schemas.microsoft.com/office/drawing/2014/main" id="{F640B49A-B203-4473-8011-CE4B05814859}"/>
               </a:ext>
             </a:extLst>
           </p:cNvPr>
@@ -4644,7 +4644,7 @@
           <p:cNvPr id="6" name="">
             <a:extLst xmlns:a="http://schemas.openxmlformats.org/drawingml/2006/main">
               <a:ext uri="{FF2B5EF4-FFF2-40B4-BE49-F238E27FC236}">
-                <a16:creationId xmlns:a16="http://schemas.microsoft.com/office/drawing/2014/main" id="{892B2E98-EA59-4B63-931A-FB9A5427DA6D}"/>
+                <a16:creationId xmlns:a16="http://schemas.microsoft.com/office/drawing/2014/main" id="{63E487A0-6D78-4D0E-B5AB-1A519AF12A00}"/>
               </a:ext>
             </a:extLst>
           </p:cNvPr>
@@ -4684,7 +4684,7 @@
                   <a:srgbClr val="3D8DFF"/>
                 </a:solidFill>
               </a:rPr>
-              <a:t>+0.0968</a:t>
+              <a:t>+0.0928</a:t>
             </a:r>
           </a:p>
         </p:txBody>
@@ -4694,7 +4694,7 @@
           <p:cNvPr id="7" name="">
             <a:extLst xmlns:a="http://schemas.openxmlformats.org/drawingml/2006/main">
               <a:ext uri="{FF2B5EF4-FFF2-40B4-BE49-F238E27FC236}">
-                <a16:creationId xmlns:a16="http://schemas.microsoft.com/office/drawing/2014/main" id="{410A44BF-97EB-4BCC-9EA2-050866BB12E9}"/>
+                <a16:creationId xmlns:a16="http://schemas.microsoft.com/office/drawing/2014/main" id="{EF5E5515-D197-4423-A21E-390A360B839D}"/>
               </a:ext>
             </a:extLst>
           </p:cNvPr>
@@ -4744,7 +4744,7 @@
           <p:cNvPr id="8" name="">
             <a:extLst xmlns:a="http://schemas.openxmlformats.org/drawingml/2006/main">
               <a:ext uri="{FF2B5EF4-FFF2-40B4-BE49-F238E27FC236}">
-                <a16:creationId xmlns:a16="http://schemas.microsoft.com/office/drawing/2014/main" id="{06151283-02C8-47FD-9882-0271A95C6D31}"/>
+                <a16:creationId xmlns:a16="http://schemas.microsoft.com/office/drawing/2014/main" id="{E0D375EA-D3D7-4694-9325-DC0C4BCF8CC5}"/>
               </a:ext>
             </a:extLst>
           </p:cNvPr>
@@ -4784,7 +4784,7 @@
                   <a:srgbClr val="3D8DFF"/>
                 </a:solidFill>
               </a:rPr>
-              <a:t>+0.1235</a:t>
+              <a:t>+0.1181</a:t>
             </a:r>
           </a:p>
         </p:txBody>
@@ -4794,7 +4794,7 @@
           <p:cNvPr id="9" name="">
             <a:extLst xmlns:a="http://schemas.openxmlformats.org/drawingml/2006/main">
               <a:ext uri="{FF2B5EF4-FFF2-40B4-BE49-F238E27FC236}">
-                <a16:creationId xmlns:a16="http://schemas.microsoft.com/office/drawing/2014/main" id="{A5DBFBF0-C4FA-4CA1-98B9-70505C936CBA}"/>
+                <a16:creationId xmlns:a16="http://schemas.microsoft.com/office/drawing/2014/main" id="{950B8B17-F2B7-4C34-A56C-18402E720E32}"/>
               </a:ext>
             </a:extLst>
           </p:cNvPr>
@@ -4844,7 +4844,7 @@
           <p:cNvPr id="10" name="">
             <a:extLst xmlns:a="http://schemas.openxmlformats.org/drawingml/2006/main">
               <a:ext uri="{FF2B5EF4-FFF2-40B4-BE49-F238E27FC236}">
-                <a16:creationId xmlns:a16="http://schemas.microsoft.com/office/drawing/2014/main" id="{E36367D2-1953-4DC3-8D47-34ADA7571EA5}"/>
+                <a16:creationId xmlns:a16="http://schemas.microsoft.com/office/drawing/2014/main" id="{7B51B435-2D8B-46AB-A63A-715330CD9E1E}"/>
               </a:ext>
             </a:extLst>
           </p:cNvPr>
@@ -4884,7 +4884,7 @@
                   <a:srgbClr val="0B0D10"/>
                 </a:solidFill>
               </a:rPr>
-              <a:t>29 条序列 macro average</a:t>
+              <a:t>39 条序列 macro average</a:t>
             </a:r>
           </a:p>
         </p:txBody>
@@ -4894,7 +4894,7 @@
           <p:cNvPr id="11" name="">
             <a:extLst xmlns:a="http://schemas.openxmlformats.org/drawingml/2006/main">
               <a:ext uri="{FF2B5EF4-FFF2-40B4-BE49-F238E27FC236}">
-                <a16:creationId xmlns:a16="http://schemas.microsoft.com/office/drawing/2014/main" id="{6F4CDA92-A9EB-4D77-A85F-8E347BA1F748}"/>
+                <a16:creationId xmlns:a16="http://schemas.microsoft.com/office/drawing/2014/main" id="{B35B1C45-8371-4007-A97F-64EF969AD8E1}"/>
               </a:ext>
             </a:extLst>
           </p:cNvPr>
@@ -4925,7 +4925,7 @@
           <p:cNvPr id="12" name="">
             <a:extLst xmlns:a="http://schemas.openxmlformats.org/drawingml/2006/main">
               <a:ext uri="{FF2B5EF4-FFF2-40B4-BE49-F238E27FC236}">
-                <a16:creationId xmlns:a16="http://schemas.microsoft.com/office/drawing/2014/main" id="{36745F38-2978-4D27-BCD7-3D639A6A8671}"/>
+                <a16:creationId xmlns:a16="http://schemas.microsoft.com/office/drawing/2014/main" id="{43C92450-A65B-4516-9955-C499732679DA}"/>
               </a:ext>
             </a:extLst>
           </p:cNvPr>
@@ -4975,7 +4975,7 @@
           <p:cNvPr id="13" name="">
             <a:extLst xmlns:a="http://schemas.openxmlformats.org/drawingml/2006/main">
               <a:ext uri="{FF2B5EF4-FFF2-40B4-BE49-F238E27FC236}">
-                <a16:creationId xmlns:a16="http://schemas.microsoft.com/office/drawing/2014/main" id="{05796A5A-7B67-4C88-926C-D4AE89835B44}"/>
+                <a16:creationId xmlns:a16="http://schemas.microsoft.com/office/drawing/2014/main" id="{25926E75-499B-4020-87CD-6597643F64B7}"/>
               </a:ext>
             </a:extLst>
           </p:cNvPr>
@@ -5023,7 +5023,7 @@
     </p:spTree>
     <p:extLst>
       <p:ext uri="{BB962C8B-B14F-4D97-AF65-F5344CB8AC3E}">
-        <p14:creationId xmlns:p14="http://schemas.microsoft.com/office/powerpoint/2010/main" val="162441523"/>
+        <p14:creationId xmlns:p14="http://schemas.microsoft.com/office/powerpoint/2010/main" val="1550509133"/>
       </p:ext>
     </p:extLst>
   </p:cSld>
@@ -5054,7 +5054,7 @@
           <p:cNvPr id="9" name="">
             <a:extLst xmlns:a="http://schemas.openxmlformats.org/drawingml/2006/main">
               <a:ext uri="{FF2B5EF4-FFF2-40B4-BE49-F238E27FC236}">
-                <a16:creationId xmlns:a16="http://schemas.microsoft.com/office/drawing/2014/main" id="{DCA97A57-CE9D-41A0-AC5E-E37A13C7C4D3}"/>
+                <a16:creationId xmlns:a16="http://schemas.microsoft.com/office/drawing/2014/main" id="{104FE92C-7265-4FB4-A251-FD47DD799C4B}"/>
               </a:ext>
             </a:extLst>
           </p:cNvPr>
@@ -5104,7 +5104,7 @@
           <p:cNvPr id="2" name="">
             <a:extLst xmlns:a="http://schemas.openxmlformats.org/drawingml/2006/main">
               <a:ext uri="{FF2B5EF4-FFF2-40B4-BE49-F238E27FC236}">
-                <a16:creationId xmlns:a16="http://schemas.microsoft.com/office/drawing/2014/main" id="{2A3471B4-5D0D-4AF2-B4F2-A5C47B528021}"/>
+                <a16:creationId xmlns:a16="http://schemas.microsoft.com/office/drawing/2014/main" id="{0433F651-1734-4894-B084-091C59CC7AFE}"/>
               </a:ext>
             </a:extLst>
           </p:cNvPr>
@@ -5154,7 +5154,7 @@
           <p:cNvPr id="3" name="">
             <a:extLst xmlns:a="http://schemas.openxmlformats.org/drawingml/2006/main">
               <a:ext uri="{FF2B5EF4-FFF2-40B4-BE49-F238E27FC236}">
-                <a16:creationId xmlns:a16="http://schemas.microsoft.com/office/drawing/2014/main" id="{1A287644-E8A8-4089-BBCE-8EAA49012861}"/>
+                <a16:creationId xmlns:a16="http://schemas.microsoft.com/office/drawing/2014/main" id="{4E068449-733D-4138-983C-4C97EEAF4C58}"/>
               </a:ext>
             </a:extLst>
           </p:cNvPr>
@@ -5873,7 +5873,7 @@
           <p:cNvPr id="5" name="">
             <a:extLst xmlns:a="http://schemas.openxmlformats.org/drawingml/2006/main">
               <a:ext uri="{FF2B5EF4-FFF2-40B4-BE49-F238E27FC236}">
-                <a16:creationId xmlns:a16="http://schemas.microsoft.com/office/drawing/2014/main" id="{50615644-91CA-44A5-85F4-67A74EBDB5C2}"/>
+                <a16:creationId xmlns:a16="http://schemas.microsoft.com/office/drawing/2014/main" id="{A3D7F086-9487-4192-A046-E024E3C4FBB4}"/>
               </a:ext>
             </a:extLst>
           </p:cNvPr>
@@ -5923,7 +5923,7 @@
           <p:cNvPr id="6" name="">
             <a:extLst xmlns:a="http://schemas.openxmlformats.org/drawingml/2006/main">
               <a:ext uri="{FF2B5EF4-FFF2-40B4-BE49-F238E27FC236}">
-                <a16:creationId xmlns:a16="http://schemas.microsoft.com/office/drawing/2014/main" id="{B2F2DAFF-B8CC-4873-A394-411D5E5227FC}"/>
+                <a16:creationId xmlns:a16="http://schemas.microsoft.com/office/drawing/2014/main" id="{0896E733-4A53-449D-9CB6-B7B36ED06B71}"/>
               </a:ext>
             </a:extLst>
           </p:cNvPr>
@@ -5954,7 +5954,7 @@
           <p:cNvPr id="7" name="">
             <a:extLst xmlns:a="http://schemas.openxmlformats.org/drawingml/2006/main">
               <a:ext uri="{FF2B5EF4-FFF2-40B4-BE49-F238E27FC236}">
-                <a16:creationId xmlns:a16="http://schemas.microsoft.com/office/drawing/2014/main" id="{3D4A1B15-C400-4AB4-955F-489E0FA3E036}"/>
+                <a16:creationId xmlns:a16="http://schemas.microsoft.com/office/drawing/2014/main" id="{45CF6333-8BF1-4D05-BF25-4DE79A6688F9}"/>
               </a:ext>
             </a:extLst>
           </p:cNvPr>
@@ -6004,7 +6004,7 @@
           <p:cNvPr id="8" name="">
             <a:extLst xmlns:a="http://schemas.openxmlformats.org/drawingml/2006/main">
               <a:ext uri="{FF2B5EF4-FFF2-40B4-BE49-F238E27FC236}">
-                <a16:creationId xmlns:a16="http://schemas.microsoft.com/office/drawing/2014/main" id="{345A8ADD-129D-4D3B-BB4D-6DF342EA24E5}"/>
+                <a16:creationId xmlns:a16="http://schemas.microsoft.com/office/drawing/2014/main" id="{40A70384-57DD-4650-A1C2-AE2086FCA6DD}"/>
               </a:ext>
             </a:extLst>
           </p:cNvPr>
@@ -6052,7 +6052,7 @@
     </p:spTree>
     <p:extLst>
       <p:ext uri="{BB962C8B-B14F-4D97-AF65-F5344CB8AC3E}">
-        <p14:creationId xmlns:p14="http://schemas.microsoft.com/office/powerpoint/2010/main" val="1057214032"/>
+        <p14:creationId xmlns:p14="http://schemas.microsoft.com/office/powerpoint/2010/main" val="56675869"/>
       </p:ext>
     </p:extLst>
   </p:cSld>
@@ -6083,7 +6083,7 @@
           <p:cNvPr id="27" name="">
             <a:extLst xmlns:a="http://schemas.openxmlformats.org/drawingml/2006/main">
               <a:ext uri="{FF2B5EF4-FFF2-40B4-BE49-F238E27FC236}">
-                <a16:creationId xmlns:a16="http://schemas.microsoft.com/office/drawing/2014/main" id="{8025A1CF-13A2-4B9E-B925-920088AE381B}"/>
+                <a16:creationId xmlns:a16="http://schemas.microsoft.com/office/drawing/2014/main" id="{4110D684-2A3C-497C-ADAB-A61C0D5CA241}"/>
               </a:ext>
             </a:extLst>
           </p:cNvPr>
@@ -6133,7 +6133,7 @@
           <p:cNvPr id="2" name="">
             <a:extLst xmlns:a="http://schemas.openxmlformats.org/drawingml/2006/main">
               <a:ext uri="{FF2B5EF4-FFF2-40B4-BE49-F238E27FC236}">
-                <a16:creationId xmlns:a16="http://schemas.microsoft.com/office/drawing/2014/main" id="{544951B0-2540-4FFA-B880-0BCDCDD94BBD}"/>
+                <a16:creationId xmlns:a16="http://schemas.microsoft.com/office/drawing/2014/main" id="{48694D2F-2E53-4664-B40A-D7D3DD2B6C03}"/>
               </a:ext>
             </a:extLst>
           </p:cNvPr>
@@ -6183,7 +6183,7 @@
           <p:cNvPr id="3" name="">
             <a:extLst xmlns:a="http://schemas.openxmlformats.org/drawingml/2006/main">
               <a:ext uri="{FF2B5EF4-FFF2-40B4-BE49-F238E27FC236}">
-                <a16:creationId xmlns:a16="http://schemas.microsoft.com/office/drawing/2014/main" id="{6CC54D4E-F0B1-473D-BC2A-EA6B9346A5E7}"/>
+                <a16:creationId xmlns:a16="http://schemas.microsoft.com/office/drawing/2014/main" id="{C57D07B1-59AE-4E36-9B9C-0ED127817C41}"/>
               </a:ext>
             </a:extLst>
           </p:cNvPr>
@@ -6233,7 +6233,7 @@
           <p:cNvPr id="4" name="">
             <a:extLst xmlns:a="http://schemas.openxmlformats.org/drawingml/2006/main">
               <a:ext uri="{FF2B5EF4-FFF2-40B4-BE49-F238E27FC236}">
-                <a16:creationId xmlns:a16="http://schemas.microsoft.com/office/drawing/2014/main" id="{970D7331-43F1-4CC7-B1F9-2C03319A8910}"/>
+                <a16:creationId xmlns:a16="http://schemas.microsoft.com/office/drawing/2014/main" id="{5E20E7E9-1AA5-418D-963E-FD61955C77F0}"/>
               </a:ext>
             </a:extLst>
           </p:cNvPr>
@@ -6264,7 +6264,7 @@
           <p:cNvPr id="5" name="">
             <a:extLst xmlns:a="http://schemas.openxmlformats.org/drawingml/2006/main">
               <a:ext uri="{FF2B5EF4-FFF2-40B4-BE49-F238E27FC236}">
-                <a16:creationId xmlns:a16="http://schemas.microsoft.com/office/drawing/2014/main" id="{6FC316AD-8A7E-4C04-BEEA-A047B75CAF7F}"/>
+                <a16:creationId xmlns:a16="http://schemas.microsoft.com/office/drawing/2014/main" id="{BF240D6A-6AC6-4BCE-8595-260E490BEDD2}"/>
               </a:ext>
             </a:extLst>
           </p:cNvPr>
@@ -6295,7 +6295,7 @@
           <p:cNvPr id="6" name="">
             <a:extLst xmlns:a="http://schemas.openxmlformats.org/drawingml/2006/main">
               <a:ext uri="{FF2B5EF4-FFF2-40B4-BE49-F238E27FC236}">
-                <a16:creationId xmlns:a16="http://schemas.microsoft.com/office/drawing/2014/main" id="{8E65E92A-D6A7-46CF-A15E-501C6E4FF0A3}"/>
+                <a16:creationId xmlns:a16="http://schemas.microsoft.com/office/drawing/2014/main" id="{E37F5F0D-6417-4F98-9FF9-38CBD4FBD492}"/>
               </a:ext>
             </a:extLst>
           </p:cNvPr>
@@ -6326,7 +6326,7 @@
           <p:cNvPr id="7" name="">
             <a:extLst xmlns:a="http://schemas.openxmlformats.org/drawingml/2006/main">
               <a:ext uri="{FF2B5EF4-FFF2-40B4-BE49-F238E27FC236}">
-                <a16:creationId xmlns:a16="http://schemas.microsoft.com/office/drawing/2014/main" id="{A8C15005-4815-4B70-B976-679979AD1E0E}"/>
+                <a16:creationId xmlns:a16="http://schemas.microsoft.com/office/drawing/2014/main" id="{1EB76DF5-E699-4282-9DDC-16990C9E0B97}"/>
               </a:ext>
             </a:extLst>
           </p:cNvPr>
@@ -6357,7 +6357,7 @@
           <p:cNvPr id="8" name="">
             <a:extLst xmlns:a="http://schemas.openxmlformats.org/drawingml/2006/main">
               <a:ext uri="{FF2B5EF4-FFF2-40B4-BE49-F238E27FC236}">
-                <a16:creationId xmlns:a16="http://schemas.microsoft.com/office/drawing/2014/main" id="{04E3BF22-9CA0-49F6-ADAF-A21F06C180DB}"/>
+                <a16:creationId xmlns:a16="http://schemas.microsoft.com/office/drawing/2014/main" id="{A4B48793-B584-4E11-AD1C-AFB2674810B7}"/>
               </a:ext>
             </a:extLst>
           </p:cNvPr>
@@ -6407,7 +6407,7 @@
           <p:cNvPr id="9" name="">
             <a:extLst xmlns:a="http://schemas.openxmlformats.org/drawingml/2006/main">
               <a:ext uri="{FF2B5EF4-FFF2-40B4-BE49-F238E27FC236}">
-                <a16:creationId xmlns:a16="http://schemas.microsoft.com/office/drawing/2014/main" id="{1CE32640-C07B-4646-9817-0F5D2893A28C}"/>
+                <a16:creationId xmlns:a16="http://schemas.microsoft.com/office/drawing/2014/main" id="{59018822-BCEF-4D70-A075-DA5588F3BE11}"/>
               </a:ext>
             </a:extLst>
           </p:cNvPr>
@@ -6457,7 +6457,7 @@
           <p:cNvPr id="10" name="">
             <a:extLst xmlns:a="http://schemas.openxmlformats.org/drawingml/2006/main">
               <a:ext uri="{FF2B5EF4-FFF2-40B4-BE49-F238E27FC236}">
-                <a16:creationId xmlns:a16="http://schemas.microsoft.com/office/drawing/2014/main" id="{169222A2-06CB-43A5-B29C-68E76BD7D34B}"/>
+                <a16:creationId xmlns:a16="http://schemas.microsoft.com/office/drawing/2014/main" id="{D80C1285-6E13-452F-B291-D7FB76FB4359}"/>
               </a:ext>
             </a:extLst>
           </p:cNvPr>
@@ -6524,7 +6524,7 @@
           <p:cNvPr id="11" name="">
             <a:extLst xmlns:a="http://schemas.openxmlformats.org/drawingml/2006/main">
               <a:ext uri="{FF2B5EF4-FFF2-40B4-BE49-F238E27FC236}">
-                <a16:creationId xmlns:a16="http://schemas.microsoft.com/office/drawing/2014/main" id="{C9A474BF-0FD0-4025-AB68-1DBA2733F486}"/>
+                <a16:creationId xmlns:a16="http://schemas.microsoft.com/office/drawing/2014/main" id="{33115B86-46F6-4807-A7BA-A503823E9187}"/>
               </a:ext>
             </a:extLst>
           </p:cNvPr>
@@ -6555,7 +6555,7 @@
           <p:cNvPr id="12" name="">
             <a:extLst xmlns:a="http://schemas.openxmlformats.org/drawingml/2006/main">
               <a:ext uri="{FF2B5EF4-FFF2-40B4-BE49-F238E27FC236}">
-                <a16:creationId xmlns:a16="http://schemas.microsoft.com/office/drawing/2014/main" id="{98FB9077-EA18-45BF-805C-03DA93098F36}"/>
+                <a16:creationId xmlns:a16="http://schemas.microsoft.com/office/drawing/2014/main" id="{84614E50-2D62-4E74-9618-1655AF0300F7}"/>
               </a:ext>
             </a:extLst>
           </p:cNvPr>
@@ -6605,7 +6605,7 @@
           <p:cNvPr id="13" name="">
             <a:extLst xmlns:a="http://schemas.openxmlformats.org/drawingml/2006/main">
               <a:ext uri="{FF2B5EF4-FFF2-40B4-BE49-F238E27FC236}">
-                <a16:creationId xmlns:a16="http://schemas.microsoft.com/office/drawing/2014/main" id="{A93E2969-C959-4D46-8698-753187109074}"/>
+                <a16:creationId xmlns:a16="http://schemas.microsoft.com/office/drawing/2014/main" id="{9E4DFCC3-8BE0-43A9-B468-AB6737FC1811}"/>
               </a:ext>
             </a:extLst>
           </p:cNvPr>
@@ -6655,7 +6655,7 @@
           <p:cNvPr id="14" name="">
             <a:extLst xmlns:a="http://schemas.openxmlformats.org/drawingml/2006/main">
               <a:ext uri="{FF2B5EF4-FFF2-40B4-BE49-F238E27FC236}">
-                <a16:creationId xmlns:a16="http://schemas.microsoft.com/office/drawing/2014/main" id="{3A0D9D0D-EC76-4D80-B683-4C0ADCF4DCA5}"/>
+                <a16:creationId xmlns:a16="http://schemas.microsoft.com/office/drawing/2014/main" id="{70DCE6A9-51BE-4BDA-9AF5-F23123A7DA62}"/>
               </a:ext>
             </a:extLst>
           </p:cNvPr>
@@ -6722,7 +6722,7 @@
           <p:cNvPr id="15" name="">
             <a:extLst xmlns:a="http://schemas.openxmlformats.org/drawingml/2006/main">
               <a:ext uri="{FF2B5EF4-FFF2-40B4-BE49-F238E27FC236}">
-                <a16:creationId xmlns:a16="http://schemas.microsoft.com/office/drawing/2014/main" id="{EE4C457C-03FF-4258-B7FA-36AB81F10CDA}"/>
+                <a16:creationId xmlns:a16="http://schemas.microsoft.com/office/drawing/2014/main" id="{BC42CA84-6CED-43FB-8CA0-816F61937F46}"/>
               </a:ext>
             </a:extLst>
           </p:cNvPr>
@@ -6753,7 +6753,7 @@
           <p:cNvPr id="16" name="">
             <a:extLst xmlns:a="http://schemas.openxmlformats.org/drawingml/2006/main">
               <a:ext uri="{FF2B5EF4-FFF2-40B4-BE49-F238E27FC236}">
-                <a16:creationId xmlns:a16="http://schemas.microsoft.com/office/drawing/2014/main" id="{63AEFCEC-48DD-48C4-A8D5-58EAD06FE953}"/>
+                <a16:creationId xmlns:a16="http://schemas.microsoft.com/office/drawing/2014/main" id="{79DFF5E9-9F37-4D0D-BB78-B8132D4B940A}"/>
               </a:ext>
             </a:extLst>
           </p:cNvPr>
@@ -6803,7 +6803,7 @@
           <p:cNvPr id="17" name="">
             <a:extLst xmlns:a="http://schemas.openxmlformats.org/drawingml/2006/main">
               <a:ext uri="{FF2B5EF4-FFF2-40B4-BE49-F238E27FC236}">
-                <a16:creationId xmlns:a16="http://schemas.microsoft.com/office/drawing/2014/main" id="{8A7097B6-46AD-4D5C-AE46-8D5766FD3796}"/>
+                <a16:creationId xmlns:a16="http://schemas.microsoft.com/office/drawing/2014/main" id="{3ECFCDE6-EB66-4E03-91ED-53C90A8AEC2B}"/>
               </a:ext>
             </a:extLst>
           </p:cNvPr>
@@ -6853,7 +6853,7 @@
           <p:cNvPr id="18" name="">
             <a:extLst xmlns:a="http://schemas.openxmlformats.org/drawingml/2006/main">
               <a:ext uri="{FF2B5EF4-FFF2-40B4-BE49-F238E27FC236}">
-                <a16:creationId xmlns:a16="http://schemas.microsoft.com/office/drawing/2014/main" id="{B7F06BD5-0577-4BFE-8090-1192258D9B3C}"/>
+                <a16:creationId xmlns:a16="http://schemas.microsoft.com/office/drawing/2014/main" id="{A917130D-9589-4A7A-8A0E-E895D24E932A}"/>
               </a:ext>
             </a:extLst>
           </p:cNvPr>
@@ -6920,7 +6920,7 @@
           <p:cNvPr id="19" name="">
             <a:extLst xmlns:a="http://schemas.openxmlformats.org/drawingml/2006/main">
               <a:ext uri="{FF2B5EF4-FFF2-40B4-BE49-F238E27FC236}">
-                <a16:creationId xmlns:a16="http://schemas.microsoft.com/office/drawing/2014/main" id="{CD63DAF0-3CDC-4D16-B5FA-DB4ADDAB6150}"/>
+                <a16:creationId xmlns:a16="http://schemas.microsoft.com/office/drawing/2014/main" id="{B090EF96-77CE-43F1-AD3B-071C43A4BC6E}"/>
               </a:ext>
             </a:extLst>
           </p:cNvPr>
@@ -6951,7 +6951,7 @@
           <p:cNvPr id="20" name="">
             <a:extLst xmlns:a="http://schemas.openxmlformats.org/drawingml/2006/main">
               <a:ext uri="{FF2B5EF4-FFF2-40B4-BE49-F238E27FC236}">
-                <a16:creationId xmlns:a16="http://schemas.microsoft.com/office/drawing/2014/main" id="{9DE1AB37-830B-440C-8D4D-F3F7F9ED9B87}"/>
+                <a16:creationId xmlns:a16="http://schemas.microsoft.com/office/drawing/2014/main" id="{3C6CB01C-74A5-4443-B4CE-43E877477D6A}"/>
               </a:ext>
             </a:extLst>
           </p:cNvPr>
@@ -7001,7 +7001,7 @@
           <p:cNvPr id="21" name="">
             <a:extLst xmlns:a="http://schemas.openxmlformats.org/drawingml/2006/main">
               <a:ext uri="{FF2B5EF4-FFF2-40B4-BE49-F238E27FC236}">
-                <a16:creationId xmlns:a16="http://schemas.microsoft.com/office/drawing/2014/main" id="{01A211C6-0615-4EA8-B07B-A7C22659B9C2}"/>
+                <a16:creationId xmlns:a16="http://schemas.microsoft.com/office/drawing/2014/main" id="{2323C1E9-CFA1-41E8-989D-BC83EF7D71D6}"/>
               </a:ext>
             </a:extLst>
           </p:cNvPr>
@@ -7051,7 +7051,7 @@
           <p:cNvPr id="22" name="">
             <a:extLst xmlns:a="http://schemas.openxmlformats.org/drawingml/2006/main">
               <a:ext uri="{FF2B5EF4-FFF2-40B4-BE49-F238E27FC236}">
-                <a16:creationId xmlns:a16="http://schemas.microsoft.com/office/drawing/2014/main" id="{106EA4A4-23F2-4789-AC24-49FD5ED915EE}"/>
+                <a16:creationId xmlns:a16="http://schemas.microsoft.com/office/drawing/2014/main" id="{872924D1-C394-41B2-BAD6-2F4A7E2AD590}"/>
               </a:ext>
             </a:extLst>
           </p:cNvPr>
@@ -7118,7 +7118,7 @@
           <p:cNvPr id="23" name="">
             <a:extLst xmlns:a="http://schemas.openxmlformats.org/drawingml/2006/main">
               <a:ext uri="{FF2B5EF4-FFF2-40B4-BE49-F238E27FC236}">
-                <a16:creationId xmlns:a16="http://schemas.microsoft.com/office/drawing/2014/main" id="{C1E5E33A-C73B-41C0-AD08-776F0CB1C8DB}"/>
+                <a16:creationId xmlns:a16="http://schemas.microsoft.com/office/drawing/2014/main" id="{818463CA-AA53-42A4-8A72-E8F281175493}"/>
               </a:ext>
             </a:extLst>
           </p:cNvPr>
@@ -7168,7 +7168,7 @@
           <p:cNvPr id="24" name="">
             <a:extLst xmlns:a="http://schemas.openxmlformats.org/drawingml/2006/main">
               <a:ext uri="{FF2B5EF4-FFF2-40B4-BE49-F238E27FC236}">
-                <a16:creationId xmlns:a16="http://schemas.microsoft.com/office/drawing/2014/main" id="{1547E212-8D64-4A83-B386-101F24B811EF}"/>
+                <a16:creationId xmlns:a16="http://schemas.microsoft.com/office/drawing/2014/main" id="{0EB906D3-11DB-4B1E-BA2F-8E972DC8B03E}"/>
               </a:ext>
             </a:extLst>
           </p:cNvPr>
@@ -7199,7 +7199,7 @@
           <p:cNvPr id="25" name="">
             <a:extLst xmlns:a="http://schemas.openxmlformats.org/drawingml/2006/main">
               <a:ext uri="{FF2B5EF4-FFF2-40B4-BE49-F238E27FC236}">
-                <a16:creationId xmlns:a16="http://schemas.microsoft.com/office/drawing/2014/main" id="{9DC68C71-5A1C-493A-ADAC-5377969B5A9E}"/>
+                <a16:creationId xmlns:a16="http://schemas.microsoft.com/office/drawing/2014/main" id="{B544B700-DCEB-41FD-9F77-7F8873B86849}"/>
               </a:ext>
             </a:extLst>
           </p:cNvPr>
@@ -7249,7 +7249,7 @@
           <p:cNvPr id="26" name="">
             <a:extLst xmlns:a="http://schemas.openxmlformats.org/drawingml/2006/main">
               <a:ext uri="{FF2B5EF4-FFF2-40B4-BE49-F238E27FC236}">
-                <a16:creationId xmlns:a16="http://schemas.microsoft.com/office/drawing/2014/main" id="{EDA018F9-B487-4BBD-9CB7-F9B213374EE7}"/>
+                <a16:creationId xmlns:a16="http://schemas.microsoft.com/office/drawing/2014/main" id="{83CDF92D-1F44-45B5-BE55-D23D196BBA51}"/>
               </a:ext>
             </a:extLst>
           </p:cNvPr>
@@ -7297,7 +7297,7 @@
     </p:spTree>
     <p:extLst>
       <p:ext uri="{BB962C8B-B14F-4D97-AF65-F5344CB8AC3E}">
-        <p14:creationId xmlns:p14="http://schemas.microsoft.com/office/powerpoint/2010/main" val="1325532146"/>
+        <p14:creationId xmlns:p14="http://schemas.microsoft.com/office/powerpoint/2010/main" val="1623463806"/>
       </p:ext>
     </p:extLst>
   </p:cSld>
@@ -7328,7 +7328,7 @@
           <p:cNvPr id="13" name="">
             <a:extLst xmlns:a="http://schemas.openxmlformats.org/drawingml/2006/main">
               <a:ext uri="{FF2B5EF4-FFF2-40B4-BE49-F238E27FC236}">
-                <a16:creationId xmlns:a16="http://schemas.microsoft.com/office/drawing/2014/main" id="{5DEC19CA-113E-4C1E-96F9-912BA1EC9C62}"/>
+                <a16:creationId xmlns:a16="http://schemas.microsoft.com/office/drawing/2014/main" id="{F2B3EB91-F972-471B-9141-E01284D25BD8}"/>
               </a:ext>
             </a:extLst>
           </p:cNvPr>
@@ -7378,7 +7378,7 @@
           <p:cNvPr id="2" name="">
             <a:extLst xmlns:a="http://schemas.openxmlformats.org/drawingml/2006/main">
               <a:ext uri="{FF2B5EF4-FFF2-40B4-BE49-F238E27FC236}">
-                <a16:creationId xmlns:a16="http://schemas.microsoft.com/office/drawing/2014/main" id="{B9D3FD18-D6BD-405D-B0AE-D9D5B51F8CED}"/>
+                <a16:creationId xmlns:a16="http://schemas.microsoft.com/office/drawing/2014/main" id="{6F40CFA4-38BB-4D02-9192-8FBAB5DE54E3}"/>
               </a:ext>
             </a:extLst>
           </p:cNvPr>
@@ -7428,7 +7428,7 @@
           <p:cNvPr id="3" name="">
             <a:extLst xmlns:a="http://schemas.openxmlformats.org/drawingml/2006/main">
               <a:ext uri="{FF2B5EF4-FFF2-40B4-BE49-F238E27FC236}">
-                <a16:creationId xmlns:a16="http://schemas.microsoft.com/office/drawing/2014/main" id="{285772F2-A9BE-4719-A4D4-F5D42C4BBCE6}"/>
+                <a16:creationId xmlns:a16="http://schemas.microsoft.com/office/drawing/2014/main" id="{23B07DCB-05C3-435A-9479-E77EB7F0DC7A}"/>
               </a:ext>
             </a:extLst>
           </p:cNvPr>
@@ -7459,7 +7459,7 @@
           <p:cNvPr id="4" name="">
             <a:extLst xmlns:a="http://schemas.openxmlformats.org/drawingml/2006/main">
               <a:ext uri="{FF2B5EF4-FFF2-40B4-BE49-F238E27FC236}">
-                <a16:creationId xmlns:a16="http://schemas.microsoft.com/office/drawing/2014/main" id="{B7B4F01B-C15D-4EAE-99F6-86F03A2E63DF}"/>
+                <a16:creationId xmlns:a16="http://schemas.microsoft.com/office/drawing/2014/main" id="{E23E287A-F0E1-4C2D-ADA2-E7620A9E8B70}"/>
               </a:ext>
             </a:extLst>
           </p:cNvPr>
@@ -7509,7 +7509,7 @@
           <p:cNvPr id="5" name="">
             <a:extLst xmlns:a="http://schemas.openxmlformats.org/drawingml/2006/main">
               <a:ext uri="{FF2B5EF4-FFF2-40B4-BE49-F238E27FC236}">
-                <a16:creationId xmlns:a16="http://schemas.microsoft.com/office/drawing/2014/main" id="{8C7E2443-7327-4D39-AB68-2C57C1CB1B62}"/>
+                <a16:creationId xmlns:a16="http://schemas.microsoft.com/office/drawing/2014/main" id="{5D0C8C51-B117-4704-8FFF-26A4A1388F55}"/>
               </a:ext>
             </a:extLst>
           </p:cNvPr>
@@ -7654,7 +7654,7 @@
           <p:cNvPr id="6" name="">
             <a:extLst xmlns:a="http://schemas.openxmlformats.org/drawingml/2006/main">
               <a:ext uri="{FF2B5EF4-FFF2-40B4-BE49-F238E27FC236}">
-                <a16:creationId xmlns:a16="http://schemas.microsoft.com/office/drawing/2014/main" id="{79C2D602-FAC2-4154-BE2C-E7F8DA0E2FF6}"/>
+                <a16:creationId xmlns:a16="http://schemas.microsoft.com/office/drawing/2014/main" id="{663C70F9-141E-4963-A869-FC6211E0B1FE}"/>
               </a:ext>
             </a:extLst>
           </p:cNvPr>
@@ -7685,7 +7685,7 @@
           <p:cNvPr id="7" name="">
             <a:extLst xmlns:a="http://schemas.openxmlformats.org/drawingml/2006/main">
               <a:ext uri="{FF2B5EF4-FFF2-40B4-BE49-F238E27FC236}">
-                <a16:creationId xmlns:a16="http://schemas.microsoft.com/office/drawing/2014/main" id="{D089F84C-BD59-4C1B-A30F-42B53FFAE4F7}"/>
+                <a16:creationId xmlns:a16="http://schemas.microsoft.com/office/drawing/2014/main" id="{7BA09D77-E86E-4D44-8B92-9864542592FA}"/>
               </a:ext>
             </a:extLst>
           </p:cNvPr>
@@ -7735,7 +7735,7 @@
           <p:cNvPr id="8" name="">
             <a:extLst xmlns:a="http://schemas.openxmlformats.org/drawingml/2006/main">
               <a:ext uri="{FF2B5EF4-FFF2-40B4-BE49-F238E27FC236}">
-                <a16:creationId xmlns:a16="http://schemas.microsoft.com/office/drawing/2014/main" id="{9F45E386-CCA3-44B1-8DD3-8371586D96E5}"/>
+                <a16:creationId xmlns:a16="http://schemas.microsoft.com/office/drawing/2014/main" id="{9F4D1D33-3CE2-422A-A760-B079B9FC7DF8}"/>
               </a:ext>
             </a:extLst>
           </p:cNvPr>
@@ -7880,7 +7880,7 @@
           <p:cNvPr id="9" name="">
             <a:extLst xmlns:a="http://schemas.openxmlformats.org/drawingml/2006/main">
               <a:ext uri="{FF2B5EF4-FFF2-40B4-BE49-F238E27FC236}">
-                <a16:creationId xmlns:a16="http://schemas.microsoft.com/office/drawing/2014/main" id="{D7700336-886B-4DB7-9958-9A55CFEFE241}"/>
+                <a16:creationId xmlns:a16="http://schemas.microsoft.com/office/drawing/2014/main" id="{DB0A6C76-5112-4031-B464-EF07CB63ACCC}"/>
               </a:ext>
             </a:extLst>
           </p:cNvPr>
@@ -7930,7 +7930,7 @@
           <p:cNvPr id="10" name="">
             <a:extLst xmlns:a="http://schemas.openxmlformats.org/drawingml/2006/main">
               <a:ext uri="{FF2B5EF4-FFF2-40B4-BE49-F238E27FC236}">
-                <a16:creationId xmlns:a16="http://schemas.microsoft.com/office/drawing/2014/main" id="{866D5F1E-820B-436D-8ED6-B4C003CAC60D}"/>
+                <a16:creationId xmlns:a16="http://schemas.microsoft.com/office/drawing/2014/main" id="{2F76130D-9273-4EEF-A0F6-59A72333F951}"/>
               </a:ext>
             </a:extLst>
           </p:cNvPr>
@@ -7961,7 +7961,7 @@
           <p:cNvPr id="11" name="">
             <a:extLst xmlns:a="http://schemas.openxmlformats.org/drawingml/2006/main">
               <a:ext uri="{FF2B5EF4-FFF2-40B4-BE49-F238E27FC236}">
-                <a16:creationId xmlns:a16="http://schemas.microsoft.com/office/drawing/2014/main" id="{CA129535-1880-4136-9014-687827A26F4D}"/>
+                <a16:creationId xmlns:a16="http://schemas.microsoft.com/office/drawing/2014/main" id="{9C9F39CB-A66A-47F2-BF19-558366E95EFF}"/>
               </a:ext>
             </a:extLst>
           </p:cNvPr>
@@ -8011,7 +8011,7 @@
           <p:cNvPr id="12" name="">
             <a:extLst xmlns:a="http://schemas.openxmlformats.org/drawingml/2006/main">
               <a:ext uri="{FF2B5EF4-FFF2-40B4-BE49-F238E27FC236}">
-                <a16:creationId xmlns:a16="http://schemas.microsoft.com/office/drawing/2014/main" id="{C17A9E99-5050-4559-B9DE-4CE3559AA2C4}"/>
+                <a16:creationId xmlns:a16="http://schemas.microsoft.com/office/drawing/2014/main" id="{9EA90ECF-7E08-4E4B-B1AD-7F38E48FF52A}"/>
               </a:ext>
             </a:extLst>
           </p:cNvPr>
@@ -8059,7 +8059,7 @@
     </p:spTree>
     <p:extLst>
       <p:ext uri="{BB962C8B-B14F-4D97-AF65-F5344CB8AC3E}">
-        <p14:creationId xmlns:p14="http://schemas.microsoft.com/office/powerpoint/2010/main" val="158053874"/>
+        <p14:creationId xmlns:p14="http://schemas.microsoft.com/office/powerpoint/2010/main" val="1701337100"/>
       </p:ext>
     </p:extLst>
   </p:cSld>
@@ -8090,7 +8090,7 @@
           <p:cNvPr id="9" name="">
             <a:extLst xmlns:a="http://schemas.openxmlformats.org/drawingml/2006/main">
               <a:ext uri="{FF2B5EF4-FFF2-40B4-BE49-F238E27FC236}">
-                <a16:creationId xmlns:a16="http://schemas.microsoft.com/office/drawing/2014/main" id="{96D346F7-85B8-4122-9C04-378EE574990C}"/>
+                <a16:creationId xmlns:a16="http://schemas.microsoft.com/office/drawing/2014/main" id="{F9C00EE4-72AA-4555-92EC-2A1D131EAF83}"/>
               </a:ext>
             </a:extLst>
           </p:cNvPr>
@@ -8121,7 +8121,7 @@
           <p:cNvPr id="2" name="">
             <a:extLst xmlns:a="http://schemas.openxmlformats.org/drawingml/2006/main">
               <a:ext uri="{FF2B5EF4-FFF2-40B4-BE49-F238E27FC236}">
-                <a16:creationId xmlns:a16="http://schemas.microsoft.com/office/drawing/2014/main" id="{CE2FD1B1-8090-4C2C-BBA8-7816F8D5EA5F}"/>
+                <a16:creationId xmlns:a16="http://schemas.microsoft.com/office/drawing/2014/main" id="{08A2B3C4-1CD4-41B6-80A1-8CD05B108826}"/>
               </a:ext>
             </a:extLst>
           </p:cNvPr>
@@ -8171,7 +8171,7 @@
           <p:cNvPr id="3" name="">
             <a:extLst xmlns:a="http://schemas.openxmlformats.org/drawingml/2006/main">
               <a:ext uri="{FF2B5EF4-FFF2-40B4-BE49-F238E27FC236}">
-                <a16:creationId xmlns:a16="http://schemas.microsoft.com/office/drawing/2014/main" id="{F2294F61-06DA-48F8-B03E-17D30B568F39}"/>
+                <a16:creationId xmlns:a16="http://schemas.microsoft.com/office/drawing/2014/main" id="{351CD40A-3203-46DC-8DDC-3761983DD78D}"/>
               </a:ext>
             </a:extLst>
           </p:cNvPr>
@@ -8221,7 +8221,7 @@
           <p:cNvPr id="4" name="">
             <a:extLst xmlns:a="http://schemas.openxmlformats.org/drawingml/2006/main">
               <a:ext uri="{FF2B5EF4-FFF2-40B4-BE49-F238E27FC236}">
-                <a16:creationId xmlns:a16="http://schemas.microsoft.com/office/drawing/2014/main" id="{92D81573-6413-4B05-9F29-434B3B63AF52}"/>
+                <a16:creationId xmlns:a16="http://schemas.microsoft.com/office/drawing/2014/main" id="{29F91FEA-EB26-4CAF-8FCC-0489F065BB6B}"/>
               </a:ext>
             </a:extLst>
           </p:cNvPr>
@@ -8271,7 +8271,7 @@
           <p:cNvPr id="5" name="">
             <a:extLst xmlns:a="http://schemas.openxmlformats.org/drawingml/2006/main">
               <a:ext uri="{FF2B5EF4-FFF2-40B4-BE49-F238E27FC236}">
-                <a16:creationId xmlns:a16="http://schemas.microsoft.com/office/drawing/2014/main" id="{F63E6D8F-ABBA-4A91-86FE-D9F3A60B8669}"/>
+                <a16:creationId xmlns:a16="http://schemas.microsoft.com/office/drawing/2014/main" id="{471ACD9D-FA83-4D6D-A929-15E3C3D2D2B6}"/>
               </a:ext>
             </a:extLst>
           </p:cNvPr>
@@ -8302,7 +8302,7 @@
           <p:cNvPr id="6" name="">
             <a:extLst xmlns:a="http://schemas.openxmlformats.org/drawingml/2006/main">
               <a:ext uri="{FF2B5EF4-FFF2-40B4-BE49-F238E27FC236}">
-                <a16:creationId xmlns:a16="http://schemas.microsoft.com/office/drawing/2014/main" id="{CD96002E-5B87-4661-A655-80611252611F}"/>
+                <a16:creationId xmlns:a16="http://schemas.microsoft.com/office/drawing/2014/main" id="{EDD82DC8-6CB6-47DF-B833-DB4DE901E001}"/>
               </a:ext>
             </a:extLst>
           </p:cNvPr>
@@ -8352,7 +8352,7 @@
           <p:cNvPr id="7" name="">
             <a:extLst xmlns:a="http://schemas.openxmlformats.org/drawingml/2006/main">
               <a:ext uri="{FF2B5EF4-FFF2-40B4-BE49-F238E27FC236}">
-                <a16:creationId xmlns:a16="http://schemas.microsoft.com/office/drawing/2014/main" id="{54AC6F41-E889-4657-B45E-D3A026C2229D}"/>
+                <a16:creationId xmlns:a16="http://schemas.microsoft.com/office/drawing/2014/main" id="{C3457800-EAF5-44DD-8CD3-7156C85DA2DF}"/>
               </a:ext>
             </a:extLst>
           </p:cNvPr>
@@ -8392,7 +8392,7 @@
                   <a:srgbClr val="0B0D10"/>
                 </a:solidFill>
               </a:rPr>
-              <a:t>29 条已汇总 · 0030–0039 已成对完成 · 0045/0046 等待数据到齐 · 120 条全量尚未宣称完成</a:t>
+              <a:t>39 条已汇总 · 0030–0039 已成对完成 · 0049/0050 等待数据到齐 · 120 条全量尚未宣称完成</a:t>
             </a:r>
           </a:p>
         </p:txBody>
@@ -8402,7 +8402,7 @@
           <p:cNvPr id="8" name="">
             <a:extLst xmlns:a="http://schemas.openxmlformats.org/drawingml/2006/main">
               <a:ext uri="{FF2B5EF4-FFF2-40B4-BE49-F238E27FC236}">
-                <a16:creationId xmlns:a16="http://schemas.microsoft.com/office/drawing/2014/main" id="{00E136FC-88EB-446D-B6F0-9620A3CD7900}"/>
+                <a16:creationId xmlns:a16="http://schemas.microsoft.com/office/drawing/2014/main" id="{C3FC2619-7926-4168-8FF5-24D0D8568CA2}"/>
               </a:ext>
             </a:extLst>
           </p:cNvPr>
@@ -8450,7 +8450,7 @@
     </p:spTree>
     <p:extLst>
       <p:ext uri="{BB962C8B-B14F-4D97-AF65-F5344CB8AC3E}">
-        <p14:creationId xmlns:p14="http://schemas.microsoft.com/office/powerpoint/2010/main" val="604672452"/>
+        <p14:creationId xmlns:p14="http://schemas.microsoft.com/office/powerpoint/2010/main" val="1928498157"/>
       </p:ext>
     </p:extLst>
   </p:cSld>

</xml_diff>

<commit_message>
docs: publish final 120-sequence GRT-360 results
</commit_message>
<xml_diff>
--- a/reports/GRT360_Research_Handoff_2026-08-09.pptx
+++ b/reports/GRT360_Research_Handoff_2026-08-09.pptx
@@ -2,21 +2,21 @@
 <file path=ppt/presentation.xml><?xml version="1.0" encoding="utf-8"?>
 <p:presentation xmlns:p="http://schemas.openxmlformats.org/presentationml/2006/main">
   <p:sldMasterIdLst>
-    <p:sldMasterId xmlns:r="http://schemas.openxmlformats.org/officeDocument/2006/relationships" id="2147483648" r:id="Re0c752bd79f7458c"/>
+    <p:sldMasterId xmlns:r="http://schemas.openxmlformats.org/officeDocument/2006/relationships" id="2147483648" r:id="R16959f676cad40a5"/>
   </p:sldMasterIdLst>
   <p:notesMasterIdLst>
-    <p:notesMasterId xmlns:r="http://schemas.openxmlformats.org/officeDocument/2006/relationships" r:id="Rf2d74faa61b54ed1"/>
+    <p:notesMasterId xmlns:r="http://schemas.openxmlformats.org/officeDocument/2006/relationships" r:id="Rffbd23ea399d4728"/>
   </p:notesMasterIdLst>
   <p:sldIdLst>
-    <p:sldId xmlns:r="http://schemas.openxmlformats.org/officeDocument/2006/relationships" id="256" r:id="R8ed0a508b63e4cee"/>
-    <p:sldId xmlns:r="http://schemas.openxmlformats.org/officeDocument/2006/relationships" id="257" r:id="R1d3f9829bee04170"/>
-    <p:sldId xmlns:r="http://schemas.openxmlformats.org/officeDocument/2006/relationships" id="258" r:id="R99126ce6193e466f"/>
-    <p:sldId xmlns:r="http://schemas.openxmlformats.org/officeDocument/2006/relationships" id="259" r:id="Rbabfcce255a24317"/>
-    <p:sldId xmlns:r="http://schemas.openxmlformats.org/officeDocument/2006/relationships" id="260" r:id="R3b8e2c525c1241b5"/>
-    <p:sldId xmlns:r="http://schemas.openxmlformats.org/officeDocument/2006/relationships" id="261" r:id="Rf3a9788fcf3a44ff"/>
-    <p:sldId xmlns:r="http://schemas.openxmlformats.org/officeDocument/2006/relationships" id="262" r:id="R6f4c045b87e74a42"/>
-    <p:sldId xmlns:r="http://schemas.openxmlformats.org/officeDocument/2006/relationships" id="263" r:id="R61bf45501a114c52"/>
-    <p:sldId xmlns:r="http://schemas.openxmlformats.org/officeDocument/2006/relationships" id="264" r:id="R9252584f0203402a"/>
+    <p:sldId xmlns:r="http://schemas.openxmlformats.org/officeDocument/2006/relationships" id="256" r:id="R61caecc40ca34ab5"/>
+    <p:sldId xmlns:r="http://schemas.openxmlformats.org/officeDocument/2006/relationships" id="257" r:id="Rf33f98656b044db4"/>
+    <p:sldId xmlns:r="http://schemas.openxmlformats.org/officeDocument/2006/relationships" id="258" r:id="R5bb7912302094c9a"/>
+    <p:sldId xmlns:r="http://schemas.openxmlformats.org/officeDocument/2006/relationships" id="259" r:id="Rbb2c31788ae145c1"/>
+    <p:sldId xmlns:r="http://schemas.openxmlformats.org/officeDocument/2006/relationships" id="260" r:id="R171f1173e5cc4cf7"/>
+    <p:sldId xmlns:r="http://schemas.openxmlformats.org/officeDocument/2006/relationships" id="261" r:id="R9a7769b8974442c9"/>
+    <p:sldId xmlns:r="http://schemas.openxmlformats.org/officeDocument/2006/relationships" id="262" r:id="R8ccf119aa77e471b"/>
+    <p:sldId xmlns:r="http://schemas.openxmlformats.org/officeDocument/2006/relationships" id="263" r:id="R3d3c633fd73546fc"/>
+    <p:sldId xmlns:r="http://schemas.openxmlformats.org/officeDocument/2006/relationships" id="264" r:id="Rc661b523a1f24ae1"/>
   </p:sldIdLst>
   <p:sldSz cx="12192000" cy="6858000"/>
   <p:notesSz cx="6858000" cy="9144000"/>
@@ -540,7 +540,7 @@
           </a:p>
           <a:p xmlns:a="http://schemas.openxmlformats.org/drawingml/2006/main">
             <a:r>
-              <a:t>- D:/instan/pano360/runs/grt360_20260809/ablation_erpwrap_39seq/bakeoff.json</a:t>
+              <a:t>- D:/instan/pano360/runs/grt360_20260809/ablation_erpwrap_120seq/bakeoff.json</a:t>
             </a:r>
           </a:p>
         </p:txBody>
@@ -775,7 +775,7 @@
           </a:p>
           <a:p xmlns:a="http://schemas.openxmlformats.org/drawingml/2006/main">
             <a:r>
-              <a:t>- D:/instan/pano360/runs/grt360_20260809/ablation_erpwrap_39seq/bakeoff.json</a:t>
+              <a:t>- D:/instan/pano360/runs/grt360_20260809/ablation_erpwrap_120seq/bakeoff.json</a:t>
             </a:r>
           </a:p>
           <a:p xmlns:a="http://schemas.openxmlformats.org/drawingml/2006/main">
@@ -855,7 +855,7 @@
           </a:p>
           <a:p xmlns:a="http://schemas.openxmlformats.org/drawingml/2006/main">
             <a:r>
-              <a:t>- D:/instan/pano360/runs/grt360_20260809/ablation_erpwrap_39seq/bakeoff.json</a:t>
+              <a:t>- D:/instan/pano360/runs/grt360_20260809/ablation_erpwrap_120seq/bakeoff.json</a:t>
             </a:r>
           </a:p>
           <a:p xmlns:a="http://schemas.openxmlformats.org/drawingml/2006/main">
@@ -1173,7 +1173,7 @@
   </p:cSld>
   <p:clrMap bg1="lt1" tx1="dk1" bg2="lt2" tx2="dk2" accent1="accent1" accent2="accent2" accent3="accent3" accent4="accent4" accent5="accent5" accent6="accent6" hlink="hlink" folHlink="folHlink"/>
   <p:sldLayoutIdLst>
-    <p:sldLayoutId xmlns:r="http://schemas.openxmlformats.org/officeDocument/2006/relationships" id="2147483649" r:id="R0d81f62c5c30487f"/>
+    <p:sldLayoutId xmlns:r="http://schemas.openxmlformats.org/officeDocument/2006/relationships" id="2147483649" r:id="Re39680a848d24256"/>
   </p:sldLayoutIdLst>
   <p:txStyles>
     <p:titleStyle>
@@ -1959,10 +1959,10 @@
               <c:formatCode>0.0</c:formatCode>
               <c:ptCount val="2"/>
               <c:pt idx="0">
-                <c:v>0.4988</c:v>
+                <c:v>0.5143</c:v>
               </c:pt>
               <c:pt idx="1">
-                <c:v>0.5578</c:v>
+                <c:v>0.5776</c:v>
               </c:pt>
             </c:numLit>
           </c:val>
@@ -1994,10 +1994,10 @@
               <c:formatCode>0.0</c:formatCode>
               <c:ptCount val="2"/>
               <c:pt idx="0">
-                <c:v>0.406</c:v>
+                <c:v>0.4168</c:v>
               </c:pt>
               <c:pt idx="1">
-                <c:v>0.4397</c:v>
+                <c:v>0.4525</c:v>
               </c:pt>
             </c:numLit>
           </c:val>
@@ -2170,7 +2170,7 @@
           <p:cNvPr id="6" name="">
             <a:extLst xmlns:a="http://schemas.openxmlformats.org/drawingml/2006/main">
               <a:ext uri="{FF2B5EF4-FFF2-40B4-BE49-F238E27FC236}">
-                <a16:creationId xmlns:a16="http://schemas.microsoft.com/office/drawing/2014/main" id="{C5466B52-1EFA-4156-A7B9-07C9AB0869C4}"/>
+                <a16:creationId xmlns:a16="http://schemas.microsoft.com/office/drawing/2014/main" id="{C6C32FE3-1A99-48D5-9033-C0E169D2E601}"/>
               </a:ext>
             </a:extLst>
           </p:cNvPr>
@@ -2201,7 +2201,7 @@
           <p:cNvPr id="2" name="">
             <a:extLst xmlns:a="http://schemas.openxmlformats.org/drawingml/2006/main">
               <a:ext uri="{FF2B5EF4-FFF2-40B4-BE49-F238E27FC236}">
-                <a16:creationId xmlns:a16="http://schemas.microsoft.com/office/drawing/2014/main" id="{05AFF9BF-D6D0-4145-876A-3754AE0015AC}"/>
+                <a16:creationId xmlns:a16="http://schemas.microsoft.com/office/drawing/2014/main" id="{B1B7DB32-8D7B-4A5F-8A76-BB8046E98772}"/>
               </a:ext>
             </a:extLst>
           </p:cNvPr>
@@ -2251,7 +2251,7 @@
           <p:cNvPr id="3" name="">
             <a:extLst xmlns:a="http://schemas.openxmlformats.org/drawingml/2006/main">
               <a:ext uri="{FF2B5EF4-FFF2-40B4-BE49-F238E27FC236}">
-                <a16:creationId xmlns:a16="http://schemas.microsoft.com/office/drawing/2014/main" id="{E46F739F-0DCE-4B3F-9966-E06E24826B9A}"/>
+                <a16:creationId xmlns:a16="http://schemas.microsoft.com/office/drawing/2014/main" id="{179EE5D6-A630-4159-959B-870B7FEE1247}"/>
               </a:ext>
             </a:extLst>
           </p:cNvPr>
@@ -2301,7 +2301,7 @@
           <p:cNvPr id="4" name="">
             <a:extLst xmlns:a="http://schemas.openxmlformats.org/drawingml/2006/main">
               <a:ext uri="{FF2B5EF4-FFF2-40B4-BE49-F238E27FC236}">
-                <a16:creationId xmlns:a16="http://schemas.microsoft.com/office/drawing/2014/main" id="{19AE557F-F964-4E3D-B584-CC69ACFEC2EC}"/>
+                <a16:creationId xmlns:a16="http://schemas.microsoft.com/office/drawing/2014/main" id="{F51B2D8B-C53A-4353-972B-2EBFD2641EB4}"/>
               </a:ext>
             </a:extLst>
           </p:cNvPr>
@@ -2351,7 +2351,7 @@
           <p:cNvPr id="5" name="">
             <a:extLst xmlns:a="http://schemas.openxmlformats.org/drawingml/2006/main">
               <a:ext uri="{FF2B5EF4-FFF2-40B4-BE49-F238E27FC236}">
-                <a16:creationId xmlns:a16="http://schemas.microsoft.com/office/drawing/2014/main" id="{4037BF07-6292-4B7C-92A5-F57CA72F73A5}"/>
+                <a16:creationId xmlns:a16="http://schemas.microsoft.com/office/drawing/2014/main" id="{A17D3B03-3729-44A9-98D4-FA60251526C0}"/>
               </a:ext>
             </a:extLst>
           </p:cNvPr>
@@ -2399,7 +2399,7 @@
     </p:spTree>
     <p:extLst>
       <p:ext uri="{BB962C8B-B14F-4D97-AF65-F5344CB8AC3E}">
-        <p14:creationId xmlns:p14="http://schemas.microsoft.com/office/powerpoint/2010/main" val="586629733"/>
+        <p14:creationId xmlns:p14="http://schemas.microsoft.com/office/powerpoint/2010/main" val="1409393464"/>
       </p:ext>
     </p:extLst>
   </p:cSld>
@@ -2430,7 +2430,7 @@
           <p:cNvPr id="19" name="">
             <a:extLst xmlns:a="http://schemas.openxmlformats.org/drawingml/2006/main">
               <a:ext uri="{FF2B5EF4-FFF2-40B4-BE49-F238E27FC236}">
-                <a16:creationId xmlns:a16="http://schemas.microsoft.com/office/drawing/2014/main" id="{D5EBD2C4-A006-4839-8DBA-689B9F3F9EDA}"/>
+                <a16:creationId xmlns:a16="http://schemas.microsoft.com/office/drawing/2014/main" id="{91BC6BF8-64DF-41EE-9467-E60C430BCA07}"/>
               </a:ext>
             </a:extLst>
           </p:cNvPr>
@@ -2480,7 +2480,7 @@
           <p:cNvPr id="2" name="">
             <a:extLst xmlns:a="http://schemas.openxmlformats.org/drawingml/2006/main">
               <a:ext uri="{FF2B5EF4-FFF2-40B4-BE49-F238E27FC236}">
-                <a16:creationId xmlns:a16="http://schemas.microsoft.com/office/drawing/2014/main" id="{12C16453-96C2-47C8-BFB4-CA576C23F4CC}"/>
+                <a16:creationId xmlns:a16="http://schemas.microsoft.com/office/drawing/2014/main" id="{AB382BB7-57A6-4DD0-AE34-7D107F73FAC0}"/>
               </a:ext>
             </a:extLst>
           </p:cNvPr>
@@ -2530,7 +2530,7 @@
           <p:cNvPr id="3" name="">
             <a:extLst xmlns:a="http://schemas.openxmlformats.org/drawingml/2006/main">
               <a:ext uri="{FF2B5EF4-FFF2-40B4-BE49-F238E27FC236}">
-                <a16:creationId xmlns:a16="http://schemas.microsoft.com/office/drawing/2014/main" id="{A728901F-6952-4B21-B294-6AE7D17912F5}"/>
+                <a16:creationId xmlns:a16="http://schemas.microsoft.com/office/drawing/2014/main" id="{203F1D6D-D0FD-44E1-AB3F-137AC0D26D42}"/>
               </a:ext>
             </a:extLst>
           </p:cNvPr>
@@ -2561,7 +2561,7 @@
           <p:cNvPr id="4" name="">
             <a:extLst xmlns:a="http://schemas.openxmlformats.org/drawingml/2006/main">
               <a:ext uri="{FF2B5EF4-FFF2-40B4-BE49-F238E27FC236}">
-                <a16:creationId xmlns:a16="http://schemas.microsoft.com/office/drawing/2014/main" id="{DD914055-48E5-4DE3-9AD1-79654CE14C76}"/>
+                <a16:creationId xmlns:a16="http://schemas.microsoft.com/office/drawing/2014/main" id="{CF3579B5-C7BF-4C2E-B6C1-51F7155E4E8D}"/>
               </a:ext>
             </a:extLst>
           </p:cNvPr>
@@ -2601,7 +2601,7 @@
                   <a:srgbClr val="0B0D10"/>
                 </a:solidFill>
               </a:rPr>
-              <a:t>主干模型已经选定，工程闭环已经打通；最后的 120 条全量分数仍由服务器队列继续产生。</a:t>
+              <a:t>主干模型已经选定，工程闭环已经打通；120 条全量分数已由服务器严格 scorer 冻结。</a:t>
             </a:r>
           </a:p>
         </p:txBody>
@@ -2611,7 +2611,7 @@
           <p:cNvPr id="5" name="">
             <a:extLst xmlns:a="http://schemas.openxmlformats.org/drawingml/2006/main">
               <a:ext uri="{FF2B5EF4-FFF2-40B4-BE49-F238E27FC236}">
-                <a16:creationId xmlns:a16="http://schemas.microsoft.com/office/drawing/2014/main" id="{E5F20254-6A06-4176-B6C3-B3B43A9C30EE}"/>
+                <a16:creationId xmlns:a16="http://schemas.microsoft.com/office/drawing/2014/main" id="{2BB44922-27DE-47D1-9936-2DB78EAC3DF1}"/>
               </a:ext>
             </a:extLst>
           </p:cNvPr>
@@ -2651,7 +2651,7 @@
                   <a:srgbClr val="3D8DFF"/>
                 </a:solidFill>
               </a:rPr>
-              <a:t>0.4988</a:t>
+              <a:t>0.5143</a:t>
             </a:r>
           </a:p>
         </p:txBody>
@@ -2661,7 +2661,7 @@
           <p:cNvPr id="6" name="">
             <a:extLst xmlns:a="http://schemas.openxmlformats.org/drawingml/2006/main">
               <a:ext uri="{FF2B5EF4-FFF2-40B4-BE49-F238E27FC236}">
-                <a16:creationId xmlns:a16="http://schemas.microsoft.com/office/drawing/2014/main" id="{F390DB62-0B31-4E87-9601-44B0F129448B}"/>
+                <a16:creationId xmlns:a16="http://schemas.microsoft.com/office/drawing/2014/main" id="{7D385472-FCF6-4D6F-A8FC-776EFDE35B84}"/>
               </a:ext>
             </a:extLst>
           </p:cNvPr>
@@ -2701,7 +2701,7 @@
                   <a:srgbClr val="5B6470"/>
                 </a:solidFill>
               </a:rPr>
-              <a:t>39 条序列 ERP-wrap AUC</a:t>
+              <a:t>120 条序列 ERP-wrap AUC</a:t>
             </a:r>
           </a:p>
         </p:txBody>
@@ -2711,7 +2711,7 @@
           <p:cNvPr id="7" name="">
             <a:extLst xmlns:a="http://schemas.openxmlformats.org/drawingml/2006/main">
               <a:ext uri="{FF2B5EF4-FFF2-40B4-BE49-F238E27FC236}">
-                <a16:creationId xmlns:a16="http://schemas.microsoft.com/office/drawing/2014/main" id="{C6844220-BD41-413C-81C8-B1EC3E609A62}"/>
+                <a16:creationId xmlns:a16="http://schemas.microsoft.com/office/drawing/2014/main" id="{15CB3DED-C540-40F1-8423-18C6EE3F6B01}"/>
               </a:ext>
             </a:extLst>
           </p:cNvPr>
@@ -2751,7 +2751,7 @@
                   <a:srgbClr val="3D8DFF"/>
                 </a:solidFill>
               </a:rPr>
-              <a:t>0.5578</a:t>
+              <a:t>0.5776</a:t>
             </a:r>
           </a:p>
         </p:txBody>
@@ -2761,7 +2761,7 @@
           <p:cNvPr id="8" name="">
             <a:extLst xmlns:a="http://schemas.openxmlformats.org/drawingml/2006/main">
               <a:ext uri="{FF2B5EF4-FFF2-40B4-BE49-F238E27FC236}">
-                <a16:creationId xmlns:a16="http://schemas.microsoft.com/office/drawing/2014/main" id="{C8DDA21D-359A-4A02-B242-BF48B6DA29FE}"/>
+                <a16:creationId xmlns:a16="http://schemas.microsoft.com/office/drawing/2014/main" id="{4B1BA8B2-52AB-4A02-8EDF-61A315D954E1}"/>
               </a:ext>
             </a:extLst>
           </p:cNvPr>
@@ -2801,7 +2801,7 @@
                   <a:srgbClr val="5B6470"/>
                 </a:solidFill>
               </a:rPr>
-              <a:t>39 条序列 ERP-wrap SR</a:t>
+              <a:t>120 条序列 ERP-wrap SR</a:t>
             </a:r>
           </a:p>
         </p:txBody>
@@ -2811,7 +2811,7 @@
           <p:cNvPr id="9" name="">
             <a:extLst xmlns:a="http://schemas.openxmlformats.org/drawingml/2006/main">
               <a:ext uri="{FF2B5EF4-FFF2-40B4-BE49-F238E27FC236}">
-                <a16:creationId xmlns:a16="http://schemas.microsoft.com/office/drawing/2014/main" id="{0825C2F1-68E4-4D6D-AA48-A9A10AC39926}"/>
+                <a16:creationId xmlns:a16="http://schemas.microsoft.com/office/drawing/2014/main" id="{FAFAEF31-AA48-4D37-8895-2309486376EE}"/>
               </a:ext>
             </a:extLst>
           </p:cNvPr>
@@ -2842,7 +2842,7 @@
           <p:cNvPr id="10" name="">
             <a:extLst xmlns:a="http://schemas.openxmlformats.org/drawingml/2006/main">
               <a:ext uri="{FF2B5EF4-FFF2-40B4-BE49-F238E27FC236}">
-                <a16:creationId xmlns:a16="http://schemas.microsoft.com/office/drawing/2014/main" id="{17AFAB5A-8310-4A76-BC8C-0D124304AFA9}"/>
+                <a16:creationId xmlns:a16="http://schemas.microsoft.com/office/drawing/2014/main" id="{C40F9D3A-D1A4-4C75-BE63-D997CA1A050B}"/>
               </a:ext>
             </a:extLst>
           </p:cNvPr>
@@ -2892,7 +2892,7 @@
           <p:cNvPr id="11" name="">
             <a:extLst xmlns:a="http://schemas.openxmlformats.org/drawingml/2006/main">
               <a:ext uri="{FF2B5EF4-FFF2-40B4-BE49-F238E27FC236}">
-                <a16:creationId xmlns:a16="http://schemas.microsoft.com/office/drawing/2014/main" id="{1CDED290-53C8-49DF-88F1-59DEE462A560}"/>
+                <a16:creationId xmlns:a16="http://schemas.microsoft.com/office/drawing/2014/main" id="{137CC6D8-2432-42B5-90A1-3E1AF07D81F0}"/>
               </a:ext>
             </a:extLst>
           </p:cNvPr>
@@ -2942,7 +2942,7 @@
           <p:cNvPr id="12" name="">
             <a:extLst xmlns:a="http://schemas.openxmlformats.org/drawingml/2006/main">
               <a:ext uri="{FF2B5EF4-FFF2-40B4-BE49-F238E27FC236}">
-                <a16:creationId xmlns:a16="http://schemas.microsoft.com/office/drawing/2014/main" id="{6B1DE86B-72DE-4DA6-96BC-0C07B3A447D3}"/>
+                <a16:creationId xmlns:a16="http://schemas.microsoft.com/office/drawing/2014/main" id="{951D9141-04C2-4294-84B8-7BCEC5EB6B8B}"/>
               </a:ext>
             </a:extLst>
           </p:cNvPr>
@@ -2972,17 +2972,17 @@
             <a:pPr algn="l">
               <a:defRPr sz="1650" b="1">
                 <a:solidFill>
-                  <a:srgbClr val="3D8DFF"/>
+                  <a:srgbClr val="147D64"/>
                 </a:solidFill>
               </a:defRPr>
             </a:pPr>
             <a:r>
               <a:rPr sz="1650" b="1">
                 <a:solidFill>
-                  <a:srgbClr val="3D8DFF"/>
-                </a:solidFill>
-              </a:rPr>
-              <a:t>正在运行</a:t>
+                  <a:srgbClr val="147D64"/>
+                </a:solidFill>
+              </a:rPr>
+              <a:t>已冻结</a:t>
             </a:r>
           </a:p>
         </p:txBody>
@@ -2992,7 +2992,7 @@
           <p:cNvPr id="13" name="">
             <a:extLst xmlns:a="http://schemas.openxmlformats.org/drawingml/2006/main">
               <a:ext uri="{FF2B5EF4-FFF2-40B4-BE49-F238E27FC236}">
-                <a16:creationId xmlns:a16="http://schemas.microsoft.com/office/drawing/2014/main" id="{E1F211C0-E678-482F-8996-EE9342D57AD2}"/>
+                <a16:creationId xmlns:a16="http://schemas.microsoft.com/office/drawing/2014/main" id="{CBCF77F6-365D-4850-9828-311DAD04B013}"/>
               </a:ext>
             </a:extLst>
           </p:cNvPr>
@@ -3032,7 +3032,7 @@
                   <a:srgbClr val="0B0D10"/>
                 </a:solidFill>
               </a:rPr>
-              <a:t>数据同步与 0030 起的成对评测队列；已有结果自动跳过，GPU 空闲后续跑。</a:t>
+              <a:t>120 条基线与 ERP-wrap 结果已完成严格对齐、汇总和归档；原始 CSV 与 tar 归档均已保存。</a:t>
             </a:r>
           </a:p>
         </p:txBody>
@@ -3042,7 +3042,7 @@
           <p:cNvPr id="14" name="">
             <a:extLst xmlns:a="http://schemas.openxmlformats.org/drawingml/2006/main">
               <a:ext uri="{FF2B5EF4-FFF2-40B4-BE49-F238E27FC236}">
-                <a16:creationId xmlns:a16="http://schemas.microsoft.com/office/drawing/2014/main" id="{7D13281E-77D4-4A6B-B3D6-76F063FEF8E9}"/>
+                <a16:creationId xmlns:a16="http://schemas.microsoft.com/office/drawing/2014/main" id="{888E3B6C-1674-43F7-86F0-CBFF74B9072F}"/>
               </a:ext>
             </a:extLst>
           </p:cNvPr>
@@ -3092,7 +3092,7 @@
           <p:cNvPr id="15" name="">
             <a:extLst xmlns:a="http://schemas.openxmlformats.org/drawingml/2006/main">
               <a:ext uri="{FF2B5EF4-FFF2-40B4-BE49-F238E27FC236}">
-                <a16:creationId xmlns:a16="http://schemas.microsoft.com/office/drawing/2014/main" id="{087B13CB-C8FB-44E2-8757-BFA082748299}"/>
+                <a16:creationId xmlns:a16="http://schemas.microsoft.com/office/drawing/2014/main" id="{0F77C496-2FE9-40CD-B36C-C54645029741}"/>
               </a:ext>
             </a:extLst>
           </p:cNvPr>
@@ -3142,7 +3142,7 @@
           <p:cNvPr id="16" name="">
             <a:extLst xmlns:a="http://schemas.openxmlformats.org/drawingml/2006/main">
               <a:ext uri="{FF2B5EF4-FFF2-40B4-BE49-F238E27FC236}">
-                <a16:creationId xmlns:a16="http://schemas.microsoft.com/office/drawing/2014/main" id="{F6F77F64-3683-46BE-B272-47916276A07D}"/>
+                <a16:creationId xmlns:a16="http://schemas.microsoft.com/office/drawing/2014/main" id="{11868C9D-2C74-48CD-9BB9-28B0D4A17721}"/>
               </a:ext>
             </a:extLst>
           </p:cNvPr>
@@ -3173,7 +3173,7 @@
           <p:cNvPr id="17" name="">
             <a:extLst xmlns:a="http://schemas.openxmlformats.org/drawingml/2006/main">
               <a:ext uri="{FF2B5EF4-FFF2-40B4-BE49-F238E27FC236}">
-                <a16:creationId xmlns:a16="http://schemas.microsoft.com/office/drawing/2014/main" id="{21D61B44-A9E1-449F-821B-D1E0B107ABEA}"/>
+                <a16:creationId xmlns:a16="http://schemas.microsoft.com/office/drawing/2014/main" id="{3140CA28-1B2E-464E-971B-938E4475D781}"/>
               </a:ext>
             </a:extLst>
           </p:cNvPr>
@@ -3223,7 +3223,7 @@
           <p:cNvPr id="18" name="">
             <a:extLst xmlns:a="http://schemas.openxmlformats.org/drawingml/2006/main">
               <a:ext uri="{FF2B5EF4-FFF2-40B4-BE49-F238E27FC236}">
-                <a16:creationId xmlns:a16="http://schemas.microsoft.com/office/drawing/2014/main" id="{14DE2014-771C-4E00-87D9-D8B8D9273C95}"/>
+                <a16:creationId xmlns:a16="http://schemas.microsoft.com/office/drawing/2014/main" id="{EE2A0FAF-2BF5-4558-B9EC-78DAF3EAFFC9}"/>
               </a:ext>
             </a:extLst>
           </p:cNvPr>
@@ -3271,7 +3271,7 @@
     </p:spTree>
     <p:extLst>
       <p:ext uri="{BB962C8B-B14F-4D97-AF65-F5344CB8AC3E}">
-        <p14:creationId xmlns:p14="http://schemas.microsoft.com/office/powerpoint/2010/main" val="1273585954"/>
+        <p14:creationId xmlns:p14="http://schemas.microsoft.com/office/powerpoint/2010/main" val="2037051201"/>
       </p:ext>
     </p:extLst>
   </p:cSld>
@@ -3302,7 +3302,7 @@
           <p:cNvPr id="9" name="">
             <a:extLst xmlns:a="http://schemas.openxmlformats.org/drawingml/2006/main">
               <a:ext uri="{FF2B5EF4-FFF2-40B4-BE49-F238E27FC236}">
-                <a16:creationId xmlns:a16="http://schemas.microsoft.com/office/drawing/2014/main" id="{9C17B6A9-0052-464F-A872-2A6D01989BA5}"/>
+                <a16:creationId xmlns:a16="http://schemas.microsoft.com/office/drawing/2014/main" id="{F27B1BA7-9DD7-4980-BB6D-1754083D2864}"/>
               </a:ext>
             </a:extLst>
           </p:cNvPr>
@@ -3352,7 +3352,7 @@
           <p:cNvPr id="2" name="">
             <a:extLst xmlns:a="http://schemas.openxmlformats.org/drawingml/2006/main">
               <a:ext uri="{FF2B5EF4-FFF2-40B4-BE49-F238E27FC236}">
-                <a16:creationId xmlns:a16="http://schemas.microsoft.com/office/drawing/2014/main" id="{2D9576DE-CAC0-4212-9E6F-D9DBD1F9F98A}"/>
+                <a16:creationId xmlns:a16="http://schemas.microsoft.com/office/drawing/2014/main" id="{FD3152A0-A0D0-4F0F-B933-8F4D37E465C8}"/>
               </a:ext>
             </a:extLst>
           </p:cNvPr>
@@ -3402,7 +3402,7 @@
           <p:cNvPr id="3" name="">
             <a:extLst xmlns:a="http://schemas.openxmlformats.org/drawingml/2006/main">
               <a:ext uri="{FF2B5EF4-FFF2-40B4-BE49-F238E27FC236}">
-                <a16:creationId xmlns:a16="http://schemas.microsoft.com/office/drawing/2014/main" id="{782299C7-FBB7-44EE-AA62-060C3D9F95EF}"/>
+                <a16:creationId xmlns:a16="http://schemas.microsoft.com/office/drawing/2014/main" id="{AAA03249-3A91-4D25-BAF7-AC5AFE86D24B}"/>
               </a:ext>
             </a:extLst>
           </p:cNvPr>
@@ -3696,7 +3696,7 @@
           <p:cNvPr id="5" name="">
             <a:extLst xmlns:a="http://schemas.openxmlformats.org/drawingml/2006/main">
               <a:ext uri="{FF2B5EF4-FFF2-40B4-BE49-F238E27FC236}">
-                <a16:creationId xmlns:a16="http://schemas.microsoft.com/office/drawing/2014/main" id="{E7842ADA-64C0-4B9C-900A-B3CE6D38CB21}"/>
+                <a16:creationId xmlns:a16="http://schemas.microsoft.com/office/drawing/2014/main" id="{BA3AE371-5276-4B85-82E9-258482C49F39}"/>
               </a:ext>
             </a:extLst>
           </p:cNvPr>
@@ -3746,7 +3746,7 @@
           <p:cNvPr id="6" name="">
             <a:extLst xmlns:a="http://schemas.openxmlformats.org/drawingml/2006/main">
               <a:ext uri="{FF2B5EF4-FFF2-40B4-BE49-F238E27FC236}">
-                <a16:creationId xmlns:a16="http://schemas.microsoft.com/office/drawing/2014/main" id="{45747E02-A334-463F-9DE1-8DEA1481515E}"/>
+                <a16:creationId xmlns:a16="http://schemas.microsoft.com/office/drawing/2014/main" id="{96613902-5FE5-4F93-B523-EEB3F171875D}"/>
               </a:ext>
             </a:extLst>
           </p:cNvPr>
@@ -3777,7 +3777,7 @@
           <p:cNvPr id="7" name="">
             <a:extLst xmlns:a="http://schemas.openxmlformats.org/drawingml/2006/main">
               <a:ext uri="{FF2B5EF4-FFF2-40B4-BE49-F238E27FC236}">
-                <a16:creationId xmlns:a16="http://schemas.microsoft.com/office/drawing/2014/main" id="{76032046-2D60-4DB4-9AC7-82E510159361}"/>
+                <a16:creationId xmlns:a16="http://schemas.microsoft.com/office/drawing/2014/main" id="{BD3E744A-E31E-4316-8FED-93232DFD01B5}"/>
               </a:ext>
             </a:extLst>
           </p:cNvPr>
@@ -3827,7 +3827,7 @@
           <p:cNvPr id="8" name="">
             <a:extLst xmlns:a="http://schemas.openxmlformats.org/drawingml/2006/main">
               <a:ext uri="{FF2B5EF4-FFF2-40B4-BE49-F238E27FC236}">
-                <a16:creationId xmlns:a16="http://schemas.microsoft.com/office/drawing/2014/main" id="{97E0113F-82C3-4337-954C-AF7D2A087533}"/>
+                <a16:creationId xmlns:a16="http://schemas.microsoft.com/office/drawing/2014/main" id="{15BC3ADA-E9D3-43F4-B05B-7A13984F5C7D}"/>
               </a:ext>
             </a:extLst>
           </p:cNvPr>
@@ -3875,7 +3875,7 @@
     </p:spTree>
     <p:extLst>
       <p:ext uri="{BB962C8B-B14F-4D97-AF65-F5344CB8AC3E}">
-        <p14:creationId xmlns:p14="http://schemas.microsoft.com/office/powerpoint/2010/main" val="713657222"/>
+        <p14:creationId xmlns:p14="http://schemas.microsoft.com/office/powerpoint/2010/main" val="2091096482"/>
       </p:ext>
     </p:extLst>
   </p:cSld>
@@ -3906,7 +3906,7 @@
           <p:cNvPr id="12" name="">
             <a:extLst xmlns:a="http://schemas.openxmlformats.org/drawingml/2006/main">
               <a:ext uri="{FF2B5EF4-FFF2-40B4-BE49-F238E27FC236}">
-                <a16:creationId xmlns:a16="http://schemas.microsoft.com/office/drawing/2014/main" id="{7287B5E4-3545-48E0-8CDE-3D6B6730CF38}"/>
+                <a16:creationId xmlns:a16="http://schemas.microsoft.com/office/drawing/2014/main" id="{B6531DE5-0009-4E47-B0B3-FC8468DC743D}"/>
               </a:ext>
             </a:extLst>
           </p:cNvPr>
@@ -3956,7 +3956,7 @@
           <p:cNvPr id="2" name="">
             <a:extLst xmlns:a="http://schemas.openxmlformats.org/drawingml/2006/main">
               <a:ext uri="{FF2B5EF4-FFF2-40B4-BE49-F238E27FC236}">
-                <a16:creationId xmlns:a16="http://schemas.microsoft.com/office/drawing/2014/main" id="{7291F4FB-F08E-4249-938E-7DC6EA2C8B0F}"/>
+                <a16:creationId xmlns:a16="http://schemas.microsoft.com/office/drawing/2014/main" id="{22BCE197-CCBF-4701-8237-5746E87172DF}"/>
               </a:ext>
             </a:extLst>
           </p:cNvPr>
@@ -4006,7 +4006,7 @@
           <p:cNvPr id="3" name="">
             <a:extLst xmlns:a="http://schemas.openxmlformats.org/drawingml/2006/main">
               <a:ext uri="{FF2B5EF4-FFF2-40B4-BE49-F238E27FC236}">
-                <a16:creationId xmlns:a16="http://schemas.microsoft.com/office/drawing/2014/main" id="{037EB5F0-9E2F-4FE9-9D7A-1841A4B87899}"/>
+                <a16:creationId xmlns:a16="http://schemas.microsoft.com/office/drawing/2014/main" id="{475936B4-6B19-45F2-BB27-776FB967B21D}"/>
               </a:ext>
             </a:extLst>
           </p:cNvPr>
@@ -4063,7 +4063,7 @@
         </p:xfrm>
         <a:graphic xmlns:a="http://schemas.openxmlformats.org/drawingml/2006/main">
           <a:graphicData uri="http://schemas.openxmlformats.org/drawingml/2006/chart">
-            <c:chart xmlns:r="http://schemas.openxmlformats.org/officeDocument/2006/relationships" xmlns:c="http://schemas.openxmlformats.org/drawingml/2006/chart" r:id="R0fa546b07bb349d5"/>
+            <c:chart xmlns:r="http://schemas.openxmlformats.org/officeDocument/2006/relationships" xmlns:c="http://schemas.openxmlformats.org/drawingml/2006/chart" r:id="Re6eb87921d344d20"/>
           </a:graphicData>
         </a:graphic>
       </p:graphicFrame>
@@ -4072,7 +4072,7 @@
           <p:cNvPr id="5" name="">
             <a:extLst xmlns:a="http://schemas.openxmlformats.org/drawingml/2006/main">
               <a:ext uri="{FF2B5EF4-FFF2-40B4-BE49-F238E27FC236}">
-                <a16:creationId xmlns:a16="http://schemas.microsoft.com/office/drawing/2014/main" id="{00CFCFCC-80B0-4DC9-8BA6-10876755A7DF}"/>
+                <a16:creationId xmlns:a16="http://schemas.microsoft.com/office/drawing/2014/main" id="{9D53344C-46BE-4981-A575-472EEE858004}"/>
               </a:ext>
             </a:extLst>
           </p:cNvPr>
@@ -4103,7 +4103,7 @@
           <p:cNvPr id="6" name="">
             <a:extLst xmlns:a="http://schemas.openxmlformats.org/drawingml/2006/main">
               <a:ext uri="{FF2B5EF4-FFF2-40B4-BE49-F238E27FC236}">
-                <a16:creationId xmlns:a16="http://schemas.microsoft.com/office/drawing/2014/main" id="{99B13CEB-1FDD-4FDE-BEB0-7B910F39A062}"/>
+                <a16:creationId xmlns:a16="http://schemas.microsoft.com/office/drawing/2014/main" id="{384B8D4B-D00E-4939-8A51-5601E480EA1C}"/>
               </a:ext>
             </a:extLst>
           </p:cNvPr>
@@ -4153,7 +4153,7 @@
           <p:cNvPr id="7" name="">
             <a:extLst xmlns:a="http://schemas.openxmlformats.org/drawingml/2006/main">
               <a:ext uri="{FF2B5EF4-FFF2-40B4-BE49-F238E27FC236}">
-                <a16:creationId xmlns:a16="http://schemas.microsoft.com/office/drawing/2014/main" id="{0FF52CBC-0D7A-45F4-AE7D-375C05A1A000}"/>
+                <a16:creationId xmlns:a16="http://schemas.microsoft.com/office/drawing/2014/main" id="{DD0176E4-A00F-473F-B255-34E393B9785F}"/>
               </a:ext>
             </a:extLst>
           </p:cNvPr>
@@ -4237,7 +4237,7 @@
           <p:cNvPr id="8" name="">
             <a:extLst xmlns:a="http://schemas.openxmlformats.org/drawingml/2006/main">
               <a:ext uri="{FF2B5EF4-FFF2-40B4-BE49-F238E27FC236}">
-                <a16:creationId xmlns:a16="http://schemas.microsoft.com/office/drawing/2014/main" id="{576E235E-4CE7-4DA4-AF30-9AC3AEA8DDEB}"/>
+                <a16:creationId xmlns:a16="http://schemas.microsoft.com/office/drawing/2014/main" id="{2DDA7400-589A-4A76-96F2-69AF54152425}"/>
               </a:ext>
             </a:extLst>
           </p:cNvPr>
@@ -4287,7 +4287,7 @@
           <p:cNvPr id="9" name="">
             <a:extLst xmlns:a="http://schemas.openxmlformats.org/drawingml/2006/main">
               <a:ext uri="{FF2B5EF4-FFF2-40B4-BE49-F238E27FC236}">
-                <a16:creationId xmlns:a16="http://schemas.microsoft.com/office/drawing/2014/main" id="{11F47902-68CF-41C6-ACFE-D84977337BC9}"/>
+                <a16:creationId xmlns:a16="http://schemas.microsoft.com/office/drawing/2014/main" id="{9FC6B5DD-6CDD-4571-98DE-90EE153C09E6}"/>
               </a:ext>
             </a:extLst>
           </p:cNvPr>
@@ -4318,7 +4318,7 @@
           <p:cNvPr id="10" name="">
             <a:extLst xmlns:a="http://schemas.openxmlformats.org/drawingml/2006/main">
               <a:ext uri="{FF2B5EF4-FFF2-40B4-BE49-F238E27FC236}">
-                <a16:creationId xmlns:a16="http://schemas.microsoft.com/office/drawing/2014/main" id="{58D195BB-BA70-46A3-AF1E-F5AD0BF9F42D}"/>
+                <a16:creationId xmlns:a16="http://schemas.microsoft.com/office/drawing/2014/main" id="{391E9F85-AF60-4C70-BE8B-91BA0E6CD181}"/>
               </a:ext>
             </a:extLst>
           </p:cNvPr>
@@ -4368,7 +4368,7 @@
           <p:cNvPr id="11" name="">
             <a:extLst xmlns:a="http://schemas.openxmlformats.org/drawingml/2006/main">
               <a:ext uri="{FF2B5EF4-FFF2-40B4-BE49-F238E27FC236}">
-                <a16:creationId xmlns:a16="http://schemas.microsoft.com/office/drawing/2014/main" id="{35925B99-3695-4AB4-8819-325FA8ADD122}"/>
+                <a16:creationId xmlns:a16="http://schemas.microsoft.com/office/drawing/2014/main" id="{3BBEC872-92A3-4492-86D8-3DFE3484BA80}"/>
               </a:ext>
             </a:extLst>
           </p:cNvPr>
@@ -4416,7 +4416,7 @@
     </p:spTree>
     <p:extLst>
       <p:ext uri="{BB962C8B-B14F-4D97-AF65-F5344CB8AC3E}">
-        <p14:creationId xmlns:p14="http://schemas.microsoft.com/office/powerpoint/2010/main" val="1374299744"/>
+        <p14:creationId xmlns:p14="http://schemas.microsoft.com/office/powerpoint/2010/main" val="786771029"/>
       </p:ext>
     </p:extLst>
   </p:cSld>
@@ -4447,7 +4447,7 @@
           <p:cNvPr id="14" name="">
             <a:extLst xmlns:a="http://schemas.openxmlformats.org/drawingml/2006/main">
               <a:ext uri="{FF2B5EF4-FFF2-40B4-BE49-F238E27FC236}">
-                <a16:creationId xmlns:a16="http://schemas.microsoft.com/office/drawing/2014/main" id="{47C5035C-A4B7-4CD2-B6CA-7B2BF2F27416}"/>
+                <a16:creationId xmlns:a16="http://schemas.microsoft.com/office/drawing/2014/main" id="{EE1E567D-0A45-4530-86C8-38CD987BD946}"/>
               </a:ext>
             </a:extLst>
           </p:cNvPr>
@@ -4497,7 +4497,7 @@
           <p:cNvPr id="2" name="">
             <a:extLst xmlns:a="http://schemas.openxmlformats.org/drawingml/2006/main">
               <a:ext uri="{FF2B5EF4-FFF2-40B4-BE49-F238E27FC236}">
-                <a16:creationId xmlns:a16="http://schemas.microsoft.com/office/drawing/2014/main" id="{FD72CA5B-5B6D-4FB8-A68E-4E11C38EF02A}"/>
+                <a16:creationId xmlns:a16="http://schemas.microsoft.com/office/drawing/2014/main" id="{8E82B09A-C4AD-41FB-B345-A249C4C31C69}"/>
               </a:ext>
             </a:extLst>
           </p:cNvPr>
@@ -4537,7 +4537,7 @@
                   <a:srgbClr val="0B0D10"/>
                 </a:solidFill>
               </a:rPr>
-              <a:t>ERP 环形采样在 39 条序列上形成稳定增益</a:t>
+              <a:t>ERP 环形采样在 120 条序列上形成稳定增益</a:t>
             </a:r>
           </a:p>
         </p:txBody>
@@ -4547,7 +4547,7 @@
           <p:cNvPr id="3" name="">
             <a:extLst xmlns:a="http://schemas.openxmlformats.org/drawingml/2006/main">
               <a:ext uri="{FF2B5EF4-FFF2-40B4-BE49-F238E27FC236}">
-                <a16:creationId xmlns:a16="http://schemas.microsoft.com/office/drawing/2014/main" id="{1E4FFC7A-D8CA-49C8-8CD9-25F6325BE182}"/>
+                <a16:creationId xmlns:a16="http://schemas.microsoft.com/office/drawing/2014/main" id="{2D387C5B-481B-47EE-9B68-32FEF31BD76A}"/>
               </a:ext>
             </a:extLst>
           </p:cNvPr>
@@ -4604,7 +4604,7 @@
         </p:xfrm>
         <a:graphic xmlns:a="http://schemas.openxmlformats.org/drawingml/2006/main">
           <a:graphicData uri="http://schemas.openxmlformats.org/drawingml/2006/chart">
-            <c:chart xmlns:r="http://schemas.openxmlformats.org/officeDocument/2006/relationships" xmlns:c="http://schemas.openxmlformats.org/drawingml/2006/chart" r:id="R3bc70531eeb24ae7"/>
+            <c:chart xmlns:r="http://schemas.openxmlformats.org/officeDocument/2006/relationships" xmlns:c="http://schemas.openxmlformats.org/drawingml/2006/chart" r:id="R71f51f5393ac4534"/>
           </a:graphicData>
         </a:graphic>
       </p:graphicFrame>
@@ -4613,7 +4613,7 @@
           <p:cNvPr id="5" name="">
             <a:extLst xmlns:a="http://schemas.openxmlformats.org/drawingml/2006/main">
               <a:ext uri="{FF2B5EF4-FFF2-40B4-BE49-F238E27FC236}">
-                <a16:creationId xmlns:a16="http://schemas.microsoft.com/office/drawing/2014/main" id="{F640B49A-B203-4473-8011-CE4B05814859}"/>
+                <a16:creationId xmlns:a16="http://schemas.microsoft.com/office/drawing/2014/main" id="{85F02446-8839-454B-9CCF-0A149513B740}"/>
               </a:ext>
             </a:extLst>
           </p:cNvPr>
@@ -4644,7 +4644,7 @@
           <p:cNvPr id="6" name="">
             <a:extLst xmlns:a="http://schemas.openxmlformats.org/drawingml/2006/main">
               <a:ext uri="{FF2B5EF4-FFF2-40B4-BE49-F238E27FC236}">
-                <a16:creationId xmlns:a16="http://schemas.microsoft.com/office/drawing/2014/main" id="{63E487A0-6D78-4D0E-B5AB-1A519AF12A00}"/>
+                <a16:creationId xmlns:a16="http://schemas.microsoft.com/office/drawing/2014/main" id="{86F31121-59D0-452A-8F07-12A17E9B3103}"/>
               </a:ext>
             </a:extLst>
           </p:cNvPr>
@@ -4684,7 +4684,7 @@
                   <a:srgbClr val="3D8DFF"/>
                 </a:solidFill>
               </a:rPr>
-              <a:t>+0.0928</a:t>
+              <a:t>+0.0975</a:t>
             </a:r>
           </a:p>
         </p:txBody>
@@ -4694,7 +4694,7 @@
           <p:cNvPr id="7" name="">
             <a:extLst xmlns:a="http://schemas.openxmlformats.org/drawingml/2006/main">
               <a:ext uri="{FF2B5EF4-FFF2-40B4-BE49-F238E27FC236}">
-                <a16:creationId xmlns:a16="http://schemas.microsoft.com/office/drawing/2014/main" id="{EF5E5515-D197-4423-A21E-390A360B839D}"/>
+                <a16:creationId xmlns:a16="http://schemas.microsoft.com/office/drawing/2014/main" id="{C59BD2FA-F1EF-4278-9166-7043EE30807D}"/>
               </a:ext>
             </a:extLst>
           </p:cNvPr>
@@ -4744,7 +4744,7 @@
           <p:cNvPr id="8" name="">
             <a:extLst xmlns:a="http://schemas.openxmlformats.org/drawingml/2006/main">
               <a:ext uri="{FF2B5EF4-FFF2-40B4-BE49-F238E27FC236}">
-                <a16:creationId xmlns:a16="http://schemas.microsoft.com/office/drawing/2014/main" id="{E0D375EA-D3D7-4694-9325-DC0C4BCF8CC5}"/>
+                <a16:creationId xmlns:a16="http://schemas.microsoft.com/office/drawing/2014/main" id="{2EAF306A-7133-48C1-891D-E298F017BBC3}"/>
               </a:ext>
             </a:extLst>
           </p:cNvPr>
@@ -4784,7 +4784,7 @@
                   <a:srgbClr val="3D8DFF"/>
                 </a:solidFill>
               </a:rPr>
-              <a:t>+0.1181</a:t>
+              <a:t>+0.1251</a:t>
             </a:r>
           </a:p>
         </p:txBody>
@@ -4794,7 +4794,7 @@
           <p:cNvPr id="9" name="">
             <a:extLst xmlns:a="http://schemas.openxmlformats.org/drawingml/2006/main">
               <a:ext uri="{FF2B5EF4-FFF2-40B4-BE49-F238E27FC236}">
-                <a16:creationId xmlns:a16="http://schemas.microsoft.com/office/drawing/2014/main" id="{950B8B17-F2B7-4C34-A56C-18402E720E32}"/>
+                <a16:creationId xmlns:a16="http://schemas.microsoft.com/office/drawing/2014/main" id="{F53AEA3F-4B1A-4C78-AA3E-5D13700A8D7B}"/>
               </a:ext>
             </a:extLst>
           </p:cNvPr>
@@ -4844,7 +4844,7 @@
           <p:cNvPr id="10" name="">
             <a:extLst xmlns:a="http://schemas.openxmlformats.org/drawingml/2006/main">
               <a:ext uri="{FF2B5EF4-FFF2-40B4-BE49-F238E27FC236}">
-                <a16:creationId xmlns:a16="http://schemas.microsoft.com/office/drawing/2014/main" id="{7B51B435-2D8B-46AB-A63A-715330CD9E1E}"/>
+                <a16:creationId xmlns:a16="http://schemas.microsoft.com/office/drawing/2014/main" id="{D459AB2A-C4C1-41A6-A006-E8F5886C45D7}"/>
               </a:ext>
             </a:extLst>
           </p:cNvPr>
@@ -4884,7 +4884,7 @@
                   <a:srgbClr val="0B0D10"/>
                 </a:solidFill>
               </a:rPr>
-              <a:t>39 条序列 macro average</a:t>
+              <a:t>120 条序列 macro average</a:t>
             </a:r>
           </a:p>
         </p:txBody>
@@ -4894,7 +4894,7 @@
           <p:cNvPr id="11" name="">
             <a:extLst xmlns:a="http://schemas.openxmlformats.org/drawingml/2006/main">
               <a:ext uri="{FF2B5EF4-FFF2-40B4-BE49-F238E27FC236}">
-                <a16:creationId xmlns:a16="http://schemas.microsoft.com/office/drawing/2014/main" id="{B35B1C45-8371-4007-A97F-64EF969AD8E1}"/>
+                <a16:creationId xmlns:a16="http://schemas.microsoft.com/office/drawing/2014/main" id="{A77B2EC2-7A41-438C-8C86-248B4208621C}"/>
               </a:ext>
             </a:extLst>
           </p:cNvPr>
@@ -4925,7 +4925,7 @@
           <p:cNvPr id="12" name="">
             <a:extLst xmlns:a="http://schemas.openxmlformats.org/drawingml/2006/main">
               <a:ext uri="{FF2B5EF4-FFF2-40B4-BE49-F238E27FC236}">
-                <a16:creationId xmlns:a16="http://schemas.microsoft.com/office/drawing/2014/main" id="{43C92450-A65B-4516-9955-C499732679DA}"/>
+                <a16:creationId xmlns:a16="http://schemas.microsoft.com/office/drawing/2014/main" id="{03C83FE5-018D-463A-A584-F3E6413B7FCC}"/>
               </a:ext>
             </a:extLst>
           </p:cNvPr>
@@ -4975,7 +4975,7 @@
           <p:cNvPr id="13" name="">
             <a:extLst xmlns:a="http://schemas.openxmlformats.org/drawingml/2006/main">
               <a:ext uri="{FF2B5EF4-FFF2-40B4-BE49-F238E27FC236}">
-                <a16:creationId xmlns:a16="http://schemas.microsoft.com/office/drawing/2014/main" id="{25926E75-499B-4020-87CD-6597643F64B7}"/>
+                <a16:creationId xmlns:a16="http://schemas.microsoft.com/office/drawing/2014/main" id="{62F95E2B-D6AA-428D-9451-3AC4B99BA979}"/>
               </a:ext>
             </a:extLst>
           </p:cNvPr>
@@ -5023,7 +5023,7 @@
     </p:spTree>
     <p:extLst>
       <p:ext uri="{BB962C8B-B14F-4D97-AF65-F5344CB8AC3E}">
-        <p14:creationId xmlns:p14="http://schemas.microsoft.com/office/powerpoint/2010/main" val="1550509133"/>
+        <p14:creationId xmlns:p14="http://schemas.microsoft.com/office/powerpoint/2010/main" val="1093997862"/>
       </p:ext>
     </p:extLst>
   </p:cSld>
@@ -5054,7 +5054,7 @@
           <p:cNvPr id="9" name="">
             <a:extLst xmlns:a="http://schemas.openxmlformats.org/drawingml/2006/main">
               <a:ext uri="{FF2B5EF4-FFF2-40B4-BE49-F238E27FC236}">
-                <a16:creationId xmlns:a16="http://schemas.microsoft.com/office/drawing/2014/main" id="{104FE92C-7265-4FB4-A251-FD47DD799C4B}"/>
+                <a16:creationId xmlns:a16="http://schemas.microsoft.com/office/drawing/2014/main" id="{5CBE84E0-D8A7-431D-9BF4-D61FDECFF5E6}"/>
               </a:ext>
             </a:extLst>
           </p:cNvPr>
@@ -5104,7 +5104,7 @@
           <p:cNvPr id="2" name="">
             <a:extLst xmlns:a="http://schemas.openxmlformats.org/drawingml/2006/main">
               <a:ext uri="{FF2B5EF4-FFF2-40B4-BE49-F238E27FC236}">
-                <a16:creationId xmlns:a16="http://schemas.microsoft.com/office/drawing/2014/main" id="{0433F651-1734-4894-B084-091C59CC7AFE}"/>
+                <a16:creationId xmlns:a16="http://schemas.microsoft.com/office/drawing/2014/main" id="{D51A4065-4B3C-48F2-9D1C-7F467F457147}"/>
               </a:ext>
             </a:extLst>
           </p:cNvPr>
@@ -5154,7 +5154,7 @@
           <p:cNvPr id="3" name="">
             <a:extLst xmlns:a="http://schemas.openxmlformats.org/drawingml/2006/main">
               <a:ext uri="{FF2B5EF4-FFF2-40B4-BE49-F238E27FC236}">
-                <a16:creationId xmlns:a16="http://schemas.microsoft.com/office/drawing/2014/main" id="{4E068449-733D-4138-983C-4C97EEAF4C58}"/>
+                <a16:creationId xmlns:a16="http://schemas.microsoft.com/office/drawing/2014/main" id="{10B301C2-5B73-4524-AA57-9A1B40E746D3}"/>
               </a:ext>
             </a:extLst>
           </p:cNvPr>
@@ -5873,7 +5873,7 @@
           <p:cNvPr id="5" name="">
             <a:extLst xmlns:a="http://schemas.openxmlformats.org/drawingml/2006/main">
               <a:ext uri="{FF2B5EF4-FFF2-40B4-BE49-F238E27FC236}">
-                <a16:creationId xmlns:a16="http://schemas.microsoft.com/office/drawing/2014/main" id="{A3D7F086-9487-4192-A046-E024E3C4FBB4}"/>
+                <a16:creationId xmlns:a16="http://schemas.microsoft.com/office/drawing/2014/main" id="{73980ACA-3AA6-4CDE-B4C1-98DE564EFF0E}"/>
               </a:ext>
             </a:extLst>
           </p:cNvPr>
@@ -5923,7 +5923,7 @@
           <p:cNvPr id="6" name="">
             <a:extLst xmlns:a="http://schemas.openxmlformats.org/drawingml/2006/main">
               <a:ext uri="{FF2B5EF4-FFF2-40B4-BE49-F238E27FC236}">
-                <a16:creationId xmlns:a16="http://schemas.microsoft.com/office/drawing/2014/main" id="{0896E733-4A53-449D-9CB6-B7B36ED06B71}"/>
+                <a16:creationId xmlns:a16="http://schemas.microsoft.com/office/drawing/2014/main" id="{F87FFFAE-3E97-4DF7-836F-78077BCF76D8}"/>
               </a:ext>
             </a:extLst>
           </p:cNvPr>
@@ -5954,7 +5954,7 @@
           <p:cNvPr id="7" name="">
             <a:extLst xmlns:a="http://schemas.openxmlformats.org/drawingml/2006/main">
               <a:ext uri="{FF2B5EF4-FFF2-40B4-BE49-F238E27FC236}">
-                <a16:creationId xmlns:a16="http://schemas.microsoft.com/office/drawing/2014/main" id="{45CF6333-8BF1-4D05-BF25-4DE79A6688F9}"/>
+                <a16:creationId xmlns:a16="http://schemas.microsoft.com/office/drawing/2014/main" id="{AB1BF4A4-A2EB-45EA-A86C-165551F55463}"/>
               </a:ext>
             </a:extLst>
           </p:cNvPr>
@@ -6004,7 +6004,7 @@
           <p:cNvPr id="8" name="">
             <a:extLst xmlns:a="http://schemas.openxmlformats.org/drawingml/2006/main">
               <a:ext uri="{FF2B5EF4-FFF2-40B4-BE49-F238E27FC236}">
-                <a16:creationId xmlns:a16="http://schemas.microsoft.com/office/drawing/2014/main" id="{40A70384-57DD-4650-A1C2-AE2086FCA6DD}"/>
+                <a16:creationId xmlns:a16="http://schemas.microsoft.com/office/drawing/2014/main" id="{9C883AB0-43DD-46F6-B8CE-2C714E4E9F86}"/>
               </a:ext>
             </a:extLst>
           </p:cNvPr>
@@ -6052,7 +6052,7 @@
     </p:spTree>
     <p:extLst>
       <p:ext uri="{BB962C8B-B14F-4D97-AF65-F5344CB8AC3E}">
-        <p14:creationId xmlns:p14="http://schemas.microsoft.com/office/powerpoint/2010/main" val="56675869"/>
+        <p14:creationId xmlns:p14="http://schemas.microsoft.com/office/powerpoint/2010/main" val="1017855910"/>
       </p:ext>
     </p:extLst>
   </p:cSld>
@@ -6083,7 +6083,7 @@
           <p:cNvPr id="27" name="">
             <a:extLst xmlns:a="http://schemas.openxmlformats.org/drawingml/2006/main">
               <a:ext uri="{FF2B5EF4-FFF2-40B4-BE49-F238E27FC236}">
-                <a16:creationId xmlns:a16="http://schemas.microsoft.com/office/drawing/2014/main" id="{4110D684-2A3C-497C-ADAB-A61C0D5CA241}"/>
+                <a16:creationId xmlns:a16="http://schemas.microsoft.com/office/drawing/2014/main" id="{A7D13E80-A0E8-42A8-95E1-9DB9EDCB87AD}"/>
               </a:ext>
             </a:extLst>
           </p:cNvPr>
@@ -6133,7 +6133,7 @@
           <p:cNvPr id="2" name="">
             <a:extLst xmlns:a="http://schemas.openxmlformats.org/drawingml/2006/main">
               <a:ext uri="{FF2B5EF4-FFF2-40B4-BE49-F238E27FC236}">
-                <a16:creationId xmlns:a16="http://schemas.microsoft.com/office/drawing/2014/main" id="{48694D2F-2E53-4664-B40A-D7D3DD2B6C03}"/>
+                <a16:creationId xmlns:a16="http://schemas.microsoft.com/office/drawing/2014/main" id="{BEA1B787-ACC5-414C-961D-D84D06ED43A5}"/>
               </a:ext>
             </a:extLst>
           </p:cNvPr>
@@ -6183,7 +6183,7 @@
           <p:cNvPr id="3" name="">
             <a:extLst xmlns:a="http://schemas.openxmlformats.org/drawingml/2006/main">
               <a:ext uri="{FF2B5EF4-FFF2-40B4-BE49-F238E27FC236}">
-                <a16:creationId xmlns:a16="http://schemas.microsoft.com/office/drawing/2014/main" id="{C57D07B1-59AE-4E36-9B9C-0ED127817C41}"/>
+                <a16:creationId xmlns:a16="http://schemas.microsoft.com/office/drawing/2014/main" id="{39F30C2E-6D1F-4D11-8AED-D2BEDFDFED08}"/>
               </a:ext>
             </a:extLst>
           </p:cNvPr>
@@ -6233,7 +6233,7 @@
           <p:cNvPr id="4" name="">
             <a:extLst xmlns:a="http://schemas.openxmlformats.org/drawingml/2006/main">
               <a:ext uri="{FF2B5EF4-FFF2-40B4-BE49-F238E27FC236}">
-                <a16:creationId xmlns:a16="http://schemas.microsoft.com/office/drawing/2014/main" id="{5E20E7E9-1AA5-418D-963E-FD61955C77F0}"/>
+                <a16:creationId xmlns:a16="http://schemas.microsoft.com/office/drawing/2014/main" id="{98E1630B-80C6-48B7-8F9D-A80D874C807B}"/>
               </a:ext>
             </a:extLst>
           </p:cNvPr>
@@ -6264,7 +6264,7 @@
           <p:cNvPr id="5" name="">
             <a:extLst xmlns:a="http://schemas.openxmlformats.org/drawingml/2006/main">
               <a:ext uri="{FF2B5EF4-FFF2-40B4-BE49-F238E27FC236}">
-                <a16:creationId xmlns:a16="http://schemas.microsoft.com/office/drawing/2014/main" id="{BF240D6A-6AC6-4BCE-8595-260E490BEDD2}"/>
+                <a16:creationId xmlns:a16="http://schemas.microsoft.com/office/drawing/2014/main" id="{80DE0435-AF67-4C28-8A18-A148676AAE10}"/>
               </a:ext>
             </a:extLst>
           </p:cNvPr>
@@ -6295,7 +6295,7 @@
           <p:cNvPr id="6" name="">
             <a:extLst xmlns:a="http://schemas.openxmlformats.org/drawingml/2006/main">
               <a:ext uri="{FF2B5EF4-FFF2-40B4-BE49-F238E27FC236}">
-                <a16:creationId xmlns:a16="http://schemas.microsoft.com/office/drawing/2014/main" id="{E37F5F0D-6417-4F98-9FF9-38CBD4FBD492}"/>
+                <a16:creationId xmlns:a16="http://schemas.microsoft.com/office/drawing/2014/main" id="{53C73CBB-3414-4B1B-8FD0-14526750F938}"/>
               </a:ext>
             </a:extLst>
           </p:cNvPr>
@@ -6326,7 +6326,7 @@
           <p:cNvPr id="7" name="">
             <a:extLst xmlns:a="http://schemas.openxmlformats.org/drawingml/2006/main">
               <a:ext uri="{FF2B5EF4-FFF2-40B4-BE49-F238E27FC236}">
-                <a16:creationId xmlns:a16="http://schemas.microsoft.com/office/drawing/2014/main" id="{1EB76DF5-E699-4282-9DDC-16990C9E0B97}"/>
+                <a16:creationId xmlns:a16="http://schemas.microsoft.com/office/drawing/2014/main" id="{4EC461C4-D773-4012-8941-304B8DF572B8}"/>
               </a:ext>
             </a:extLst>
           </p:cNvPr>
@@ -6357,7 +6357,7 @@
           <p:cNvPr id="8" name="">
             <a:extLst xmlns:a="http://schemas.openxmlformats.org/drawingml/2006/main">
               <a:ext uri="{FF2B5EF4-FFF2-40B4-BE49-F238E27FC236}">
-                <a16:creationId xmlns:a16="http://schemas.microsoft.com/office/drawing/2014/main" id="{A4B48793-B584-4E11-AD1C-AFB2674810B7}"/>
+                <a16:creationId xmlns:a16="http://schemas.microsoft.com/office/drawing/2014/main" id="{268A54CA-C1BC-46BF-9118-EB3FAFE21031}"/>
               </a:ext>
             </a:extLst>
           </p:cNvPr>
@@ -6407,7 +6407,7 @@
           <p:cNvPr id="9" name="">
             <a:extLst xmlns:a="http://schemas.openxmlformats.org/drawingml/2006/main">
               <a:ext uri="{FF2B5EF4-FFF2-40B4-BE49-F238E27FC236}">
-                <a16:creationId xmlns:a16="http://schemas.microsoft.com/office/drawing/2014/main" id="{59018822-BCEF-4D70-A075-DA5588F3BE11}"/>
+                <a16:creationId xmlns:a16="http://schemas.microsoft.com/office/drawing/2014/main" id="{D5D75811-6C99-4D61-B4CC-588AB9412E03}"/>
               </a:ext>
             </a:extLst>
           </p:cNvPr>
@@ -6457,7 +6457,7 @@
           <p:cNvPr id="10" name="">
             <a:extLst xmlns:a="http://schemas.openxmlformats.org/drawingml/2006/main">
               <a:ext uri="{FF2B5EF4-FFF2-40B4-BE49-F238E27FC236}">
-                <a16:creationId xmlns:a16="http://schemas.microsoft.com/office/drawing/2014/main" id="{D80C1285-6E13-452F-B291-D7FB76FB4359}"/>
+                <a16:creationId xmlns:a16="http://schemas.microsoft.com/office/drawing/2014/main" id="{5801D69D-77E8-4F08-88FC-5EEFA04F67A2}"/>
               </a:ext>
             </a:extLst>
           </p:cNvPr>
@@ -6524,7 +6524,7 @@
           <p:cNvPr id="11" name="">
             <a:extLst xmlns:a="http://schemas.openxmlformats.org/drawingml/2006/main">
               <a:ext uri="{FF2B5EF4-FFF2-40B4-BE49-F238E27FC236}">
-                <a16:creationId xmlns:a16="http://schemas.microsoft.com/office/drawing/2014/main" id="{33115B86-46F6-4807-A7BA-A503823E9187}"/>
+                <a16:creationId xmlns:a16="http://schemas.microsoft.com/office/drawing/2014/main" id="{13A950D1-3798-4FB5-AD56-99DA06452CD7}"/>
               </a:ext>
             </a:extLst>
           </p:cNvPr>
@@ -6555,7 +6555,7 @@
           <p:cNvPr id="12" name="">
             <a:extLst xmlns:a="http://schemas.openxmlformats.org/drawingml/2006/main">
               <a:ext uri="{FF2B5EF4-FFF2-40B4-BE49-F238E27FC236}">
-                <a16:creationId xmlns:a16="http://schemas.microsoft.com/office/drawing/2014/main" id="{84614E50-2D62-4E74-9618-1655AF0300F7}"/>
+                <a16:creationId xmlns:a16="http://schemas.microsoft.com/office/drawing/2014/main" id="{79D01085-88E2-4FB7-AF1D-8748C68C12FC}"/>
               </a:ext>
             </a:extLst>
           </p:cNvPr>
@@ -6605,7 +6605,7 @@
           <p:cNvPr id="13" name="">
             <a:extLst xmlns:a="http://schemas.openxmlformats.org/drawingml/2006/main">
               <a:ext uri="{FF2B5EF4-FFF2-40B4-BE49-F238E27FC236}">
-                <a16:creationId xmlns:a16="http://schemas.microsoft.com/office/drawing/2014/main" id="{9E4DFCC3-8BE0-43A9-B468-AB6737FC1811}"/>
+                <a16:creationId xmlns:a16="http://schemas.microsoft.com/office/drawing/2014/main" id="{833673F1-6485-4436-8F1B-78039BEC95D5}"/>
               </a:ext>
             </a:extLst>
           </p:cNvPr>
@@ -6655,7 +6655,7 @@
           <p:cNvPr id="14" name="">
             <a:extLst xmlns:a="http://schemas.openxmlformats.org/drawingml/2006/main">
               <a:ext uri="{FF2B5EF4-FFF2-40B4-BE49-F238E27FC236}">
-                <a16:creationId xmlns:a16="http://schemas.microsoft.com/office/drawing/2014/main" id="{70DCE6A9-51BE-4BDA-9AF5-F23123A7DA62}"/>
+                <a16:creationId xmlns:a16="http://schemas.microsoft.com/office/drawing/2014/main" id="{B53E8117-7D20-4048-B9CF-E360E58EA956}"/>
               </a:ext>
             </a:extLst>
           </p:cNvPr>
@@ -6722,7 +6722,7 @@
           <p:cNvPr id="15" name="">
             <a:extLst xmlns:a="http://schemas.openxmlformats.org/drawingml/2006/main">
               <a:ext uri="{FF2B5EF4-FFF2-40B4-BE49-F238E27FC236}">
-                <a16:creationId xmlns:a16="http://schemas.microsoft.com/office/drawing/2014/main" id="{BC42CA84-6CED-43FB-8CA0-816F61937F46}"/>
+                <a16:creationId xmlns:a16="http://schemas.microsoft.com/office/drawing/2014/main" id="{371C3F92-FFF4-4779-BC0A-100A9A142B1D}"/>
               </a:ext>
             </a:extLst>
           </p:cNvPr>
@@ -6753,7 +6753,7 @@
           <p:cNvPr id="16" name="">
             <a:extLst xmlns:a="http://schemas.openxmlformats.org/drawingml/2006/main">
               <a:ext uri="{FF2B5EF4-FFF2-40B4-BE49-F238E27FC236}">
-                <a16:creationId xmlns:a16="http://schemas.microsoft.com/office/drawing/2014/main" id="{79DFF5E9-9F37-4D0D-BB78-B8132D4B940A}"/>
+                <a16:creationId xmlns:a16="http://schemas.microsoft.com/office/drawing/2014/main" id="{4B5AA93F-62A2-4AB0-97FE-42E25317A9A7}"/>
               </a:ext>
             </a:extLst>
           </p:cNvPr>
@@ -6803,7 +6803,7 @@
           <p:cNvPr id="17" name="">
             <a:extLst xmlns:a="http://schemas.openxmlformats.org/drawingml/2006/main">
               <a:ext uri="{FF2B5EF4-FFF2-40B4-BE49-F238E27FC236}">
-                <a16:creationId xmlns:a16="http://schemas.microsoft.com/office/drawing/2014/main" id="{3ECFCDE6-EB66-4E03-91ED-53C90A8AEC2B}"/>
+                <a16:creationId xmlns:a16="http://schemas.microsoft.com/office/drawing/2014/main" id="{DC77A7D1-2AB2-4973-B323-92ECB71403FA}"/>
               </a:ext>
             </a:extLst>
           </p:cNvPr>
@@ -6853,7 +6853,7 @@
           <p:cNvPr id="18" name="">
             <a:extLst xmlns:a="http://schemas.openxmlformats.org/drawingml/2006/main">
               <a:ext uri="{FF2B5EF4-FFF2-40B4-BE49-F238E27FC236}">
-                <a16:creationId xmlns:a16="http://schemas.microsoft.com/office/drawing/2014/main" id="{A917130D-9589-4A7A-8A0E-E895D24E932A}"/>
+                <a16:creationId xmlns:a16="http://schemas.microsoft.com/office/drawing/2014/main" id="{272FF5B0-13E9-47CB-A46C-952410B28E5E}"/>
               </a:ext>
             </a:extLst>
           </p:cNvPr>
@@ -6920,7 +6920,7 @@
           <p:cNvPr id="19" name="">
             <a:extLst xmlns:a="http://schemas.openxmlformats.org/drawingml/2006/main">
               <a:ext uri="{FF2B5EF4-FFF2-40B4-BE49-F238E27FC236}">
-                <a16:creationId xmlns:a16="http://schemas.microsoft.com/office/drawing/2014/main" id="{B090EF96-77CE-43F1-AD3B-071C43A4BC6E}"/>
+                <a16:creationId xmlns:a16="http://schemas.microsoft.com/office/drawing/2014/main" id="{8C11727B-10F1-4714-8881-AB05FF91567F}"/>
               </a:ext>
             </a:extLst>
           </p:cNvPr>
@@ -6951,7 +6951,7 @@
           <p:cNvPr id="20" name="">
             <a:extLst xmlns:a="http://schemas.openxmlformats.org/drawingml/2006/main">
               <a:ext uri="{FF2B5EF4-FFF2-40B4-BE49-F238E27FC236}">
-                <a16:creationId xmlns:a16="http://schemas.microsoft.com/office/drawing/2014/main" id="{3C6CB01C-74A5-4443-B4CE-43E877477D6A}"/>
+                <a16:creationId xmlns:a16="http://schemas.microsoft.com/office/drawing/2014/main" id="{D88C4A1C-07CE-471A-88BF-BD8533B6EF5F}"/>
               </a:ext>
             </a:extLst>
           </p:cNvPr>
@@ -7001,7 +7001,7 @@
           <p:cNvPr id="21" name="">
             <a:extLst xmlns:a="http://schemas.openxmlformats.org/drawingml/2006/main">
               <a:ext uri="{FF2B5EF4-FFF2-40B4-BE49-F238E27FC236}">
-                <a16:creationId xmlns:a16="http://schemas.microsoft.com/office/drawing/2014/main" id="{2323C1E9-CFA1-41E8-989D-BC83EF7D71D6}"/>
+                <a16:creationId xmlns:a16="http://schemas.microsoft.com/office/drawing/2014/main" id="{FF5E2FC0-F565-4DA2-8EEF-D30FD3C94511}"/>
               </a:ext>
             </a:extLst>
           </p:cNvPr>
@@ -7051,7 +7051,7 @@
           <p:cNvPr id="22" name="">
             <a:extLst xmlns:a="http://schemas.openxmlformats.org/drawingml/2006/main">
               <a:ext uri="{FF2B5EF4-FFF2-40B4-BE49-F238E27FC236}">
-                <a16:creationId xmlns:a16="http://schemas.microsoft.com/office/drawing/2014/main" id="{872924D1-C394-41B2-BAD6-2F4A7E2AD590}"/>
+                <a16:creationId xmlns:a16="http://schemas.microsoft.com/office/drawing/2014/main" id="{6EDA8AD5-610C-4E75-844C-477DB249A9B5}"/>
               </a:ext>
             </a:extLst>
           </p:cNvPr>
@@ -7118,7 +7118,7 @@
           <p:cNvPr id="23" name="">
             <a:extLst xmlns:a="http://schemas.openxmlformats.org/drawingml/2006/main">
               <a:ext uri="{FF2B5EF4-FFF2-40B4-BE49-F238E27FC236}">
-                <a16:creationId xmlns:a16="http://schemas.microsoft.com/office/drawing/2014/main" id="{818463CA-AA53-42A4-8A72-E8F281175493}"/>
+                <a16:creationId xmlns:a16="http://schemas.microsoft.com/office/drawing/2014/main" id="{55984744-0043-432D-A85B-B896A08BF827}"/>
               </a:ext>
             </a:extLst>
           </p:cNvPr>
@@ -7168,7 +7168,7 @@
           <p:cNvPr id="24" name="">
             <a:extLst xmlns:a="http://schemas.openxmlformats.org/drawingml/2006/main">
               <a:ext uri="{FF2B5EF4-FFF2-40B4-BE49-F238E27FC236}">
-                <a16:creationId xmlns:a16="http://schemas.microsoft.com/office/drawing/2014/main" id="{0EB906D3-11DB-4B1E-BA2F-8E972DC8B03E}"/>
+                <a16:creationId xmlns:a16="http://schemas.microsoft.com/office/drawing/2014/main" id="{7C96673D-E698-4879-9FEF-05E154201BC7}"/>
               </a:ext>
             </a:extLst>
           </p:cNvPr>
@@ -7199,7 +7199,7 @@
           <p:cNvPr id="25" name="">
             <a:extLst xmlns:a="http://schemas.openxmlformats.org/drawingml/2006/main">
               <a:ext uri="{FF2B5EF4-FFF2-40B4-BE49-F238E27FC236}">
-                <a16:creationId xmlns:a16="http://schemas.microsoft.com/office/drawing/2014/main" id="{B544B700-DCEB-41FD-9F77-7F8873B86849}"/>
+                <a16:creationId xmlns:a16="http://schemas.microsoft.com/office/drawing/2014/main" id="{80B37D6D-F74E-44F7-8CBB-B0537571A8BF}"/>
               </a:ext>
             </a:extLst>
           </p:cNvPr>
@@ -7249,7 +7249,7 @@
           <p:cNvPr id="26" name="">
             <a:extLst xmlns:a="http://schemas.openxmlformats.org/drawingml/2006/main">
               <a:ext uri="{FF2B5EF4-FFF2-40B4-BE49-F238E27FC236}">
-                <a16:creationId xmlns:a16="http://schemas.microsoft.com/office/drawing/2014/main" id="{83CDF92D-1F44-45B5-BE55-D23D196BBA51}"/>
+                <a16:creationId xmlns:a16="http://schemas.microsoft.com/office/drawing/2014/main" id="{EB1C666E-AA52-4ECB-A8A5-1F52FAE66FBB}"/>
               </a:ext>
             </a:extLst>
           </p:cNvPr>
@@ -7297,7 +7297,7 @@
     </p:spTree>
     <p:extLst>
       <p:ext uri="{BB962C8B-B14F-4D97-AF65-F5344CB8AC3E}">
-        <p14:creationId xmlns:p14="http://schemas.microsoft.com/office/powerpoint/2010/main" val="1623463806"/>
+        <p14:creationId xmlns:p14="http://schemas.microsoft.com/office/powerpoint/2010/main" val="1261902700"/>
       </p:ext>
     </p:extLst>
   </p:cSld>
@@ -7328,7 +7328,7 @@
           <p:cNvPr id="13" name="">
             <a:extLst xmlns:a="http://schemas.openxmlformats.org/drawingml/2006/main">
               <a:ext uri="{FF2B5EF4-FFF2-40B4-BE49-F238E27FC236}">
-                <a16:creationId xmlns:a16="http://schemas.microsoft.com/office/drawing/2014/main" id="{F2B3EB91-F972-471B-9141-E01284D25BD8}"/>
+                <a16:creationId xmlns:a16="http://schemas.microsoft.com/office/drawing/2014/main" id="{8F38908D-A51B-43E9-BBBB-2857AE92EEAC}"/>
               </a:ext>
             </a:extLst>
           </p:cNvPr>
@@ -7378,7 +7378,7 @@
           <p:cNvPr id="2" name="">
             <a:extLst xmlns:a="http://schemas.openxmlformats.org/drawingml/2006/main">
               <a:ext uri="{FF2B5EF4-FFF2-40B4-BE49-F238E27FC236}">
-                <a16:creationId xmlns:a16="http://schemas.microsoft.com/office/drawing/2014/main" id="{6F40CFA4-38BB-4D02-9192-8FBAB5DE54E3}"/>
+                <a16:creationId xmlns:a16="http://schemas.microsoft.com/office/drawing/2014/main" id="{B6B0C8BD-6764-4B77-ADD6-442F0292046E}"/>
               </a:ext>
             </a:extLst>
           </p:cNvPr>
@@ -7428,7 +7428,7 @@
           <p:cNvPr id="3" name="">
             <a:extLst xmlns:a="http://schemas.openxmlformats.org/drawingml/2006/main">
               <a:ext uri="{FF2B5EF4-FFF2-40B4-BE49-F238E27FC236}">
-                <a16:creationId xmlns:a16="http://schemas.microsoft.com/office/drawing/2014/main" id="{23B07DCB-05C3-435A-9479-E77EB7F0DC7A}"/>
+                <a16:creationId xmlns:a16="http://schemas.microsoft.com/office/drawing/2014/main" id="{47BA6CFD-9952-4249-AA99-4714C4E6570A}"/>
               </a:ext>
             </a:extLst>
           </p:cNvPr>
@@ -7459,7 +7459,7 @@
           <p:cNvPr id="4" name="">
             <a:extLst xmlns:a="http://schemas.openxmlformats.org/drawingml/2006/main">
               <a:ext uri="{FF2B5EF4-FFF2-40B4-BE49-F238E27FC236}">
-                <a16:creationId xmlns:a16="http://schemas.microsoft.com/office/drawing/2014/main" id="{E23E287A-F0E1-4C2D-ADA2-E7620A9E8B70}"/>
+                <a16:creationId xmlns:a16="http://schemas.microsoft.com/office/drawing/2014/main" id="{7A205652-4338-412F-BAE3-B487D6610361}"/>
               </a:ext>
             </a:extLst>
           </p:cNvPr>
@@ -7509,7 +7509,7 @@
           <p:cNvPr id="5" name="">
             <a:extLst xmlns:a="http://schemas.openxmlformats.org/drawingml/2006/main">
               <a:ext uri="{FF2B5EF4-FFF2-40B4-BE49-F238E27FC236}">
-                <a16:creationId xmlns:a16="http://schemas.microsoft.com/office/drawing/2014/main" id="{5D0C8C51-B117-4704-8FFF-26A4A1388F55}"/>
+                <a16:creationId xmlns:a16="http://schemas.microsoft.com/office/drawing/2014/main" id="{0C77818D-FEB4-4940-979F-FD1C0DBD01D3}"/>
               </a:ext>
             </a:extLst>
           </p:cNvPr>
@@ -7654,7 +7654,7 @@
           <p:cNvPr id="6" name="">
             <a:extLst xmlns:a="http://schemas.openxmlformats.org/drawingml/2006/main">
               <a:ext uri="{FF2B5EF4-FFF2-40B4-BE49-F238E27FC236}">
-                <a16:creationId xmlns:a16="http://schemas.microsoft.com/office/drawing/2014/main" id="{663C70F9-141E-4963-A869-FC6211E0B1FE}"/>
+                <a16:creationId xmlns:a16="http://schemas.microsoft.com/office/drawing/2014/main" id="{9809E2E1-460B-48D8-B6F0-9018BAE5E333}"/>
               </a:ext>
             </a:extLst>
           </p:cNvPr>
@@ -7685,7 +7685,7 @@
           <p:cNvPr id="7" name="">
             <a:extLst xmlns:a="http://schemas.openxmlformats.org/drawingml/2006/main">
               <a:ext uri="{FF2B5EF4-FFF2-40B4-BE49-F238E27FC236}">
-                <a16:creationId xmlns:a16="http://schemas.microsoft.com/office/drawing/2014/main" id="{7BA09D77-E86E-4D44-8B92-9864542592FA}"/>
+                <a16:creationId xmlns:a16="http://schemas.microsoft.com/office/drawing/2014/main" id="{3F716DE0-385B-41AA-BC14-6824F4C675A4}"/>
               </a:ext>
             </a:extLst>
           </p:cNvPr>
@@ -7735,7 +7735,7 @@
           <p:cNvPr id="8" name="">
             <a:extLst xmlns:a="http://schemas.openxmlformats.org/drawingml/2006/main">
               <a:ext uri="{FF2B5EF4-FFF2-40B4-BE49-F238E27FC236}">
-                <a16:creationId xmlns:a16="http://schemas.microsoft.com/office/drawing/2014/main" id="{9F4D1D33-3CE2-422A-A760-B079B9FC7DF8}"/>
+                <a16:creationId xmlns:a16="http://schemas.microsoft.com/office/drawing/2014/main" id="{EE15DA21-39B1-4BB7-AFCD-D5E7BF9F8202}"/>
               </a:ext>
             </a:extLst>
           </p:cNvPr>
@@ -7880,7 +7880,7 @@
           <p:cNvPr id="9" name="">
             <a:extLst xmlns:a="http://schemas.openxmlformats.org/drawingml/2006/main">
               <a:ext uri="{FF2B5EF4-FFF2-40B4-BE49-F238E27FC236}">
-                <a16:creationId xmlns:a16="http://schemas.microsoft.com/office/drawing/2014/main" id="{DB0A6C76-5112-4031-B464-EF07CB63ACCC}"/>
+                <a16:creationId xmlns:a16="http://schemas.microsoft.com/office/drawing/2014/main" id="{FA869972-BA0A-48C6-BD80-2B2A270763DC}"/>
               </a:ext>
             </a:extLst>
           </p:cNvPr>
@@ -7930,7 +7930,7 @@
           <p:cNvPr id="10" name="">
             <a:extLst xmlns:a="http://schemas.openxmlformats.org/drawingml/2006/main">
               <a:ext uri="{FF2B5EF4-FFF2-40B4-BE49-F238E27FC236}">
-                <a16:creationId xmlns:a16="http://schemas.microsoft.com/office/drawing/2014/main" id="{2F76130D-9273-4EEF-A0F6-59A72333F951}"/>
+                <a16:creationId xmlns:a16="http://schemas.microsoft.com/office/drawing/2014/main" id="{FE3C5826-90B5-46D9-BB65-0FD6965F96EE}"/>
               </a:ext>
             </a:extLst>
           </p:cNvPr>
@@ -7961,7 +7961,7 @@
           <p:cNvPr id="11" name="">
             <a:extLst xmlns:a="http://schemas.openxmlformats.org/drawingml/2006/main">
               <a:ext uri="{FF2B5EF4-FFF2-40B4-BE49-F238E27FC236}">
-                <a16:creationId xmlns:a16="http://schemas.microsoft.com/office/drawing/2014/main" id="{9C9F39CB-A66A-47F2-BF19-558366E95EFF}"/>
+                <a16:creationId xmlns:a16="http://schemas.microsoft.com/office/drawing/2014/main" id="{6AFEF1D4-3B91-477B-9A29-58E111F057CC}"/>
               </a:ext>
             </a:extLst>
           </p:cNvPr>
@@ -8011,7 +8011,7 @@
           <p:cNvPr id="12" name="">
             <a:extLst xmlns:a="http://schemas.openxmlformats.org/drawingml/2006/main">
               <a:ext uri="{FF2B5EF4-FFF2-40B4-BE49-F238E27FC236}">
-                <a16:creationId xmlns:a16="http://schemas.microsoft.com/office/drawing/2014/main" id="{9EA90ECF-7E08-4E4B-B1AD-7F38E48FF52A}"/>
+                <a16:creationId xmlns:a16="http://schemas.microsoft.com/office/drawing/2014/main" id="{23B77EE2-B343-4D42-8830-00EE0672EDA5}"/>
               </a:ext>
             </a:extLst>
           </p:cNvPr>
@@ -8059,7 +8059,7 @@
     </p:spTree>
     <p:extLst>
       <p:ext uri="{BB962C8B-B14F-4D97-AF65-F5344CB8AC3E}">
-        <p14:creationId xmlns:p14="http://schemas.microsoft.com/office/powerpoint/2010/main" val="1701337100"/>
+        <p14:creationId xmlns:p14="http://schemas.microsoft.com/office/powerpoint/2010/main" val="663496607"/>
       </p:ext>
     </p:extLst>
   </p:cSld>
@@ -8090,7 +8090,7 @@
           <p:cNvPr id="9" name="">
             <a:extLst xmlns:a="http://schemas.openxmlformats.org/drawingml/2006/main">
               <a:ext uri="{FF2B5EF4-FFF2-40B4-BE49-F238E27FC236}">
-                <a16:creationId xmlns:a16="http://schemas.microsoft.com/office/drawing/2014/main" id="{F9C00EE4-72AA-4555-92EC-2A1D131EAF83}"/>
+                <a16:creationId xmlns:a16="http://schemas.microsoft.com/office/drawing/2014/main" id="{C04DCAB8-7CBD-40F0-B120-73E6951C4741}"/>
               </a:ext>
             </a:extLst>
           </p:cNvPr>
@@ -8121,7 +8121,7 @@
           <p:cNvPr id="2" name="">
             <a:extLst xmlns:a="http://schemas.openxmlformats.org/drawingml/2006/main">
               <a:ext uri="{FF2B5EF4-FFF2-40B4-BE49-F238E27FC236}">
-                <a16:creationId xmlns:a16="http://schemas.microsoft.com/office/drawing/2014/main" id="{08A2B3C4-1CD4-41B6-80A1-8CD05B108826}"/>
+                <a16:creationId xmlns:a16="http://schemas.microsoft.com/office/drawing/2014/main" id="{1C01C4DA-8F61-48B1-A339-8392D841FB55}"/>
               </a:ext>
             </a:extLst>
           </p:cNvPr>
@@ -8171,7 +8171,7 @@
           <p:cNvPr id="3" name="">
             <a:extLst xmlns:a="http://schemas.openxmlformats.org/drawingml/2006/main">
               <a:ext uri="{FF2B5EF4-FFF2-40B4-BE49-F238E27FC236}">
-                <a16:creationId xmlns:a16="http://schemas.microsoft.com/office/drawing/2014/main" id="{351CD40A-3203-46DC-8DDC-3761983DD78D}"/>
+                <a16:creationId xmlns:a16="http://schemas.microsoft.com/office/drawing/2014/main" id="{B30AB63E-FFA0-436D-99B1-1D960D97F3B7}"/>
               </a:ext>
             </a:extLst>
           </p:cNvPr>
@@ -8211,7 +8211,7 @@
                   <a:srgbClr val="0B0D10"/>
                 </a:solidFill>
               </a:rPr>
-              <a:t>让全量队列跑完，再冻结最终 120 条结论。</a:t>
+              <a:t>120 条全量结论已经冻结，交付物全部归档。</a:t>
             </a:r>
           </a:p>
         </p:txBody>
@@ -8221,7 +8221,7 @@
           <p:cNvPr id="4" name="">
             <a:extLst xmlns:a="http://schemas.openxmlformats.org/drawingml/2006/main">
               <a:ext uri="{FF2B5EF4-FFF2-40B4-BE49-F238E27FC236}">
-                <a16:creationId xmlns:a16="http://schemas.microsoft.com/office/drawing/2014/main" id="{29F91FEA-EB26-4CAF-8FCC-0489F065BB6B}"/>
+                <a16:creationId xmlns:a16="http://schemas.microsoft.com/office/drawing/2014/main" id="{8C7D69A5-88EF-49B6-9606-44DB8F23CA7E}"/>
               </a:ext>
             </a:extLst>
           </p:cNvPr>
@@ -8233,7 +8233,7 @@
         <p:spPr>
           <a:xfrm xmlns:a="http://schemas.openxmlformats.org/drawingml/2006/main">
             <a:off x="1009650" y="2800350"/>
-            <a:ext cx="8191500" cy="514350"/>
+            <a:ext cx="8572500" cy="514350"/>
           </a:xfrm>
           <a:prstGeom xmlns:a="http://schemas.openxmlformats.org/drawingml/2006/main" prst="rect">
             <a:avLst/>
@@ -8261,7 +8261,7 @@
                   <a:srgbClr val="5B6470"/>
                 </a:solidFill>
               </a:rPr>
-              <a:t>当前已具备：可比较的协议、已验证的主干、可解释的几何增强、断网镜像和服务器后台队列。</a:t>
+              <a:t>当前已具备：可比较的协议、已验证的主干、可解释的几何增强、断网镜像、原始结果和最终 scorer。</a:t>
             </a:r>
           </a:p>
         </p:txBody>
@@ -8271,7 +8271,7 @@
           <p:cNvPr id="5" name="">
             <a:extLst xmlns:a="http://schemas.openxmlformats.org/drawingml/2006/main">
               <a:ext uri="{FF2B5EF4-FFF2-40B4-BE49-F238E27FC236}">
-                <a16:creationId xmlns:a16="http://schemas.microsoft.com/office/drawing/2014/main" id="{471ACD9D-FA83-4D6D-A929-15E3C3D2D2B6}"/>
+                <a16:creationId xmlns:a16="http://schemas.microsoft.com/office/drawing/2014/main" id="{D34413FF-0C0F-4624-83C4-6450F6BBA66B}"/>
               </a:ext>
             </a:extLst>
           </p:cNvPr>
@@ -8302,7 +8302,7 @@
           <p:cNvPr id="6" name="">
             <a:extLst xmlns:a="http://schemas.openxmlformats.org/drawingml/2006/main">
               <a:ext uri="{FF2B5EF4-FFF2-40B4-BE49-F238E27FC236}">
-                <a16:creationId xmlns:a16="http://schemas.microsoft.com/office/drawing/2014/main" id="{EDD82DC8-6CB6-47DF-B833-DB4DE901E001}"/>
+                <a16:creationId xmlns:a16="http://schemas.microsoft.com/office/drawing/2014/main" id="{99485E80-13E9-4037-8834-A62E2F7E3B82}"/>
               </a:ext>
             </a:extLst>
           </p:cNvPr>
@@ -8352,7 +8352,7 @@
           <p:cNvPr id="7" name="">
             <a:extLst xmlns:a="http://schemas.openxmlformats.org/drawingml/2006/main">
               <a:ext uri="{FF2B5EF4-FFF2-40B4-BE49-F238E27FC236}">
-                <a16:creationId xmlns:a16="http://schemas.microsoft.com/office/drawing/2014/main" id="{C3457800-EAF5-44DD-8CD3-7156C85DA2DF}"/>
+                <a16:creationId xmlns:a16="http://schemas.microsoft.com/office/drawing/2014/main" id="{74234552-A203-49CC-B686-06C35ADE6857}"/>
               </a:ext>
             </a:extLst>
           </p:cNvPr>
@@ -8364,7 +8364,7 @@
         <p:spPr>
           <a:xfrm xmlns:a="http://schemas.openxmlformats.org/drawingml/2006/main">
             <a:off x="1009650" y="4705350"/>
-            <a:ext cx="9525000" cy="476250"/>
+            <a:ext cx="10001250" cy="476250"/>
           </a:xfrm>
           <a:prstGeom xmlns:a="http://schemas.openxmlformats.org/drawingml/2006/main" prst="rect">
             <a:avLst/>
@@ -8392,7 +8392,7 @@
                   <a:srgbClr val="0B0D10"/>
                 </a:solidFill>
               </a:rPr>
-              <a:t>39 条已汇总 · 0030–0039 已成对完成 · 0049/0050 等待数据到齐 · 120 条全量尚未宣称完成</a:t>
+              <a:t>120 条已汇总 · 基线与 ERP-wrap 各 120 条 · 严格 scorer 已完成 · JSON/CSV/tar 已归档</a:t>
             </a:r>
           </a:p>
         </p:txBody>
@@ -8402,7 +8402,7 @@
           <p:cNvPr id="8" name="">
             <a:extLst xmlns:a="http://schemas.openxmlformats.org/drawingml/2006/main">
               <a:ext uri="{FF2B5EF4-FFF2-40B4-BE49-F238E27FC236}">
-                <a16:creationId xmlns:a16="http://schemas.microsoft.com/office/drawing/2014/main" id="{C3FC2619-7926-4168-8FF5-24D0D8568CA2}"/>
+                <a16:creationId xmlns:a16="http://schemas.microsoft.com/office/drawing/2014/main" id="{5521A165-746E-4657-B84C-A37649D807B0}"/>
               </a:ext>
             </a:extLst>
           </p:cNvPr>
@@ -8414,7 +8414,7 @@
         <p:spPr>
           <a:xfrm xmlns:a="http://schemas.openxmlformats.org/drawingml/2006/main">
             <a:off x="1009650" y="5791200"/>
-            <a:ext cx="7239000" cy="228600"/>
+            <a:ext cx="8191500" cy="228600"/>
           </a:xfrm>
           <a:prstGeom xmlns:a="http://schemas.openxmlformats.org/drawingml/2006/main" prst="rect">
             <a:avLst/>
@@ -8442,7 +8442,7 @@
                   <a:srgbClr val="5B6470"/>
                 </a:solidFill>
               </a:rPr>
-              <a:t>下一次更新：全量 score + 最终报告 + PR 更新。</a:t>
+              <a:t>交付完成：最终报告、PPT、原始结果归档与 GitHub PR 已同步。</a:t>
             </a:r>
           </a:p>
         </p:txBody>
@@ -8450,7 +8450,7 @@
     </p:spTree>
     <p:extLst>
       <p:ext uri="{BB962C8B-B14F-4D97-AF65-F5344CB8AC3E}">
-        <p14:creationId xmlns:p14="http://schemas.microsoft.com/office/powerpoint/2010/main" val="1928498157"/>
+        <p14:creationId xmlns:p14="http://schemas.microsoft.com/office/powerpoint/2010/main" val="899989425"/>
       </p:ext>
     </p:extLst>
   </p:cSld>

</xml_diff>